<commit_message>
Explain what registers are on the Registers slide.
Co-authored-by: Cursor <cursoragent@cursor.com>
</commit_message>
<xml_diff>
--- a/Reverse Engineering 101.pptx
+++ b/Reverse Engineering 101.pptx
@@ -3465,41 +3465,6 @@
       </p:sp>
       <p:sp>
         <p:nvSpPr>
-          <p:cNvPr id="4" name="TextBox 3"/>
-          <p:cNvSpPr txBox="1"/>
-          <p:nvPr/>
-        </p:nvSpPr>
-        <p:spPr>
-          <a:xfrm>
-            <a:off x="457200" y="960120"/>
-            <a:ext cx="11247120" cy="365760"/>
-          </a:xfrm>
-          <a:prstGeom prst="rect">
-            <a:avLst/>
-          </a:prstGeom>
-          <a:noFill/>
-        </p:spPr>
-        <p:txBody>
-          <a:bodyPr wrap="square">
-            <a:spAutoFit/>
-          </a:bodyPr>
-          <a:lstStyle/>
-          <a:p>
-            <a:pPr algn="l"/>
-            <a:r>
-              <a:rPr sz="1700" b="0">
-                <a:solidFill>
-                  <a:srgbClr val="B0B0B0"/>
-                </a:solidFill>
-                <a:latin typeface="Calibri"/>
-              </a:rPr>
-              <a:t>Debian / Ubuntu / WSL. New terminal after GEF so it loads.</a:t>
-            </a:r>
-          </a:p>
-        </p:txBody>
-      </p:sp>
-      <p:sp>
-        <p:nvSpPr>
           <p:cNvPr id="5" name="Rectangle 4"/>
           <p:cNvSpPr/>
           <p:nvPr/>
@@ -3889,41 +3854,6 @@
       </p:sp>
       <p:sp>
         <p:nvSpPr>
-          <p:cNvPr id="4" name="TextBox 3"/>
-          <p:cNvSpPr txBox="1"/>
-          <p:nvPr/>
-        </p:nvSpPr>
-        <p:spPr>
-          <a:xfrm>
-            <a:off x="457200" y="960120"/>
-            <a:ext cx="11247120" cy="365760"/>
-          </a:xfrm>
-          <a:prstGeom prst="rect">
-            <a:avLst/>
-          </a:prstGeom>
-          <a:noFill/>
-        </p:spPr>
-        <p:txBody>
-          <a:bodyPr wrap="square">
-            <a:spAutoFit/>
-          </a:bodyPr>
-          <a:lstStyle/>
-          <a:p>
-            <a:pPr algn="l"/>
-            <a:r>
-              <a:rPr sz="1700" b="0">
-                <a:solidFill>
-                  <a:srgbClr val="B0B0B0"/>
-                </a:solidFill>
-                <a:latin typeface="Calibri"/>
-              </a:rPr>
-              <a:t>32-bit. If gcc complains about -m32, you missed gcc-multilib.</a:t>
-            </a:r>
-          </a:p>
-        </p:txBody>
-      </p:sp>
-      <p:sp>
-        <p:nvSpPr>
           <p:cNvPr id="5" name="Rectangle 4"/>
           <p:cNvSpPr/>
           <p:nvPr/>
@@ -4454,41 +4384,6 @@
       </p:sp>
       <p:sp>
         <p:nvSpPr>
-          <p:cNvPr id="4" name="TextBox 3"/>
-          <p:cNvSpPr txBox="1"/>
-          <p:nvPr/>
-        </p:nvSpPr>
-        <p:spPr>
-          <a:xfrm>
-            <a:off x="457200" y="914400"/>
-            <a:ext cx="11247120" cy="411480"/>
-          </a:xfrm>
-          <a:prstGeom prst="rect">
-            <a:avLst/>
-          </a:prstGeom>
-          <a:noFill/>
-        </p:spPr>
-        <p:txBody>
-          <a:bodyPr wrap="square">
-            <a:spAutoFit/>
-          </a:bodyPr>
-          <a:lstStyle/>
-          <a:p>
-            <a:pPr algn="l"/>
-            <a:r>
-              <a:rPr sz="1700" b="0">
-                <a:solidFill>
-                  <a:srgbClr val="B0B0B0"/>
-                </a:solidFill>
-                <a:latin typeface="Calibri"/>
-              </a:rPr>
-              <a:t>Terminal: hexedit. GUI: Bless.  sudo apt install hexedit bless</a:t>
-            </a:r>
-          </a:p>
-        </p:txBody>
-      </p:sp>
-      <p:sp>
-        <p:nvSpPr>
           <p:cNvPr id="5" name="Rectangle 4"/>
           <p:cNvSpPr/>
           <p:nvPr/>
@@ -5104,30 +4999,45 @@
         </p:nvSpPr>
         <p:spPr>
           <a:xfrm>
-            <a:off x="457200" y="1051560"/>
-            <a:ext cx="11247120" cy="640080"/>
-          </a:xfrm>
-          <a:prstGeom prst="rect">
-            <a:avLst/>
-          </a:prstGeom>
-          <a:noFill/>
-        </p:spPr>
-        <p:txBody>
-          <a:bodyPr wrap="square">
-            <a:spAutoFit/>
-          </a:bodyPr>
-          <a:lstStyle/>
-          <a:p>
-            <a:pPr algn="l"/>
-            <a:r>
-              <a:rPr sz="2000" b="0">
+            <a:off x="365760" y="1097280"/>
+            <a:ext cx="11247120" cy="400110"/>
+          </a:xfrm>
+          <a:prstGeom prst="rect">
+            <a:avLst/>
+          </a:prstGeom>
+          <a:noFill/>
+        </p:spPr>
+        <p:txBody>
+          <a:bodyPr wrap="square">
+            <a:spAutoFit/>
+          </a:bodyPr>
+          <a:lstStyle/>
+          <a:p>
+            <a:pPr algn="l"/>
+            <a:r>
+              <a:rPr sz="2000" b="0" dirty="0">
                 <a:solidFill>
                   <a:srgbClr val="F2F2F2"/>
                 </a:solidFill>
                 <a:latin typeface="Calibri"/>
               </a:rPr>
-              <a:t>Each instruction does one small thing: move, add, compare, jump.</a:t>
-            </a:r>
+              <a:t>Each instruction does one small thing</a:t>
+            </a:r>
+            <a:r>
+              <a:rPr lang="en-IN" sz="2000" dirty="0">
+                <a:solidFill>
+                  <a:srgbClr val="F2F2F2"/>
+                </a:solidFill>
+                <a:latin typeface="Calibri"/>
+              </a:rPr>
+              <a:t>.</a:t>
+            </a:r>
+            <a:endParaRPr sz="2000" b="0" dirty="0">
+              <a:solidFill>
+                <a:srgbClr val="F2F2F2"/>
+              </a:solidFill>
+              <a:latin typeface="Calibri"/>
+            </a:endParaRPr>
           </a:p>
         </p:txBody>
       </p:sp>
@@ -5722,41 +5632,6 @@
           </a:p>
         </p:txBody>
       </p:sp>
-      <p:sp>
-        <p:nvSpPr>
-          <p:cNvPr id="4" name="TextBox 3"/>
-          <p:cNvSpPr txBox="1"/>
-          <p:nvPr/>
-        </p:nvSpPr>
-        <p:spPr>
-          <a:xfrm>
-            <a:off x="457200" y="914400"/>
-            <a:ext cx="11247120" cy="365760"/>
-          </a:xfrm>
-          <a:prstGeom prst="rect">
-            <a:avLst/>
-          </a:prstGeom>
-          <a:noFill/>
-        </p:spPr>
-        <p:txBody>
-          <a:bodyPr wrap="square">
-            <a:spAutoFit/>
-          </a:bodyPr>
-          <a:lstStyle/>
-          <a:p>
-            <a:pPr algn="l"/>
-            <a:r>
-              <a:rPr sz="1800" b="0">
-                <a:solidFill>
-                  <a:srgbClr val="B0B0B0"/>
-                </a:solidFill>
-                <a:latin typeface="Calibri"/>
-              </a:rPr>
-              <a:t>Fast storage inside the CPU. Most work happens here.</a:t>
-            </a:r>
-          </a:p>
-        </p:txBody>
-      </p:sp>
       <p:pic>
         <p:nvPicPr>
           <p:cNvPr id="5" name="Picture 4" descr="x86_registers.png"/>
@@ -6452,6 +6327,41 @@
                 <a:latin typeface="Calibri"/>
               </a:rPr>
               <a:t>14 / 27</a:t>
+            </a:r>
+          </a:p>
+        </p:txBody>
+      </p:sp>
+      <p:sp>
+        <p:nvSpPr>
+          <p:cNvPr id="25" name="TextBox 24"/>
+          <p:cNvSpPr txBox="1"/>
+          <p:nvPr/>
+        </p:nvSpPr>
+        <p:spPr>
+          <a:xfrm>
+            <a:off x="411480" y="841248"/>
+            <a:ext cx="11338560" cy="411480"/>
+          </a:xfrm>
+          <a:prstGeom prst="rect">
+            <a:avLst/>
+          </a:prstGeom>
+          <a:noFill/>
+        </p:spPr>
+        <p:txBody>
+          <a:bodyPr wrap="square">
+            <a:spAutoFit/>
+          </a:bodyPr>
+          <a:lstStyle/>
+          <a:p>
+            <a:pPr algn="l"/>
+            <a:r>
+              <a:rPr sz="1800" b="0">
+                <a:solidFill>
+                  <a:srgbClr val="B0B0B0"/>
+                </a:solidFill>
+                <a:latin typeface="Calibri"/>
+              </a:rPr>
+              <a:t>Small storage inside the CPU. Instructions use these instead of hitting memory every time.</a:t>
             </a:r>
           </a:p>
         </p:txBody>
@@ -21342,13 +21252,40 @@
           <a:p>
             <a:pPr algn="l"/>
             <a:r>
-              <a:rPr sz="1800" b="0">
+              <a:rPr sz="1800" b="0" dirty="0" err="1">
                 <a:solidFill>
                   <a:srgbClr val="B0B0B0"/>
                 </a:solidFill>
                 <a:latin typeface="Calibri"/>
               </a:rPr>
-              <a:t>objdump / Ghidra / IDA / Binary Ninja all start by turning bytes into instructions.</a:t>
+              <a:t>objdump</a:t>
+            </a:r>
+            <a:r>
+              <a:rPr sz="1800" b="0" dirty="0">
+                <a:solidFill>
+                  <a:srgbClr val="B0B0B0"/>
+                </a:solidFill>
+                <a:latin typeface="Calibri"/>
+              </a:rPr>
+              <a:t> / </a:t>
+            </a:r>
+            <a:r>
+              <a:rPr sz="1800" b="0" dirty="0" err="1">
+                <a:solidFill>
+                  <a:srgbClr val="B0B0B0"/>
+                </a:solidFill>
+                <a:latin typeface="Calibri"/>
+              </a:rPr>
+              <a:t>Ghidra</a:t>
+            </a:r>
+            <a:r>
+              <a:rPr sz="1800" b="0" dirty="0">
+                <a:solidFill>
+                  <a:srgbClr val="B0B0B0"/>
+                </a:solidFill>
+                <a:latin typeface="Calibri"/>
+              </a:rPr>
+              <a:t> / IDA / Binary Ninja all start by turning bytes into instructions.</a:t>
             </a:r>
           </a:p>
         </p:txBody>
@@ -22168,56 +22105,6 @@
               </a:rPr>
               <a:t>Tools</a:t>
             </a:r>
-          </a:p>
-        </p:txBody>
-      </p:sp>
-      <p:sp>
-        <p:nvSpPr>
-          <p:cNvPr id="4" name="TextBox 3"/>
-          <p:cNvSpPr txBox="1"/>
-          <p:nvPr/>
-        </p:nvSpPr>
-        <p:spPr>
-          <a:xfrm>
-            <a:off x="457200" y="914400"/>
-            <a:ext cx="11247120" cy="369332"/>
-          </a:xfrm>
-          <a:prstGeom prst="rect">
-            <a:avLst/>
-          </a:prstGeom>
-          <a:noFill/>
-        </p:spPr>
-        <p:txBody>
-          <a:bodyPr wrap="square">
-            <a:spAutoFit/>
-          </a:bodyPr>
-          <a:lstStyle/>
-          <a:p>
-            <a:pPr algn="l"/>
-            <a:r>
-              <a:rPr sz="1800" b="0" dirty="0">
-                <a:solidFill>
-                  <a:srgbClr val="B0B0B0"/>
-                </a:solidFill>
-                <a:latin typeface="Calibri"/>
-              </a:rPr>
-              <a:t>Today is 32-bit </a:t>
-            </a:r>
-            <a:r>
-              <a:rPr sz="1800" b="0">
-                <a:solidFill>
-                  <a:srgbClr val="B0B0B0"/>
-                </a:solidFill>
-                <a:latin typeface="Calibri"/>
-              </a:rPr>
-              <a:t>Linux ELF.</a:t>
-            </a:r>
-            <a:endParaRPr sz="1800" b="0" dirty="0">
-              <a:solidFill>
-                <a:srgbClr val="B0B0B0"/>
-              </a:solidFill>
-              <a:latin typeface="Calibri"/>
-            </a:endParaRPr>
           </a:p>
         </p:txBody>
       </p:sp>

</xml_diff>

<commit_message>
Make instruction challenges ask about specific lines.
Co-authored-by: Cursor <cursoragent@cursor.com>
</commit_message>
<xml_diff>
--- a/Reverse Engineering 101.pptx
+++ b/Reverse Engineering 101.pptx
@@ -10647,21 +10647,41 @@
         </p:nvSpPr>
         <p:spPr>
           <a:xfrm>
-            <a:off x="6766560" y="1783080"/>
-            <a:ext cx="4800600" cy="4206240"/>
-          </a:xfrm>
-          <a:prstGeom prst="rect">
-            <a:avLst/>
-          </a:prstGeom>
-          <a:noFill/>
-        </p:spPr>
-        <p:txBody>
-          <a:bodyPr wrap="square">
-            <a:spAutoFit/>
-          </a:bodyPr>
-          <a:lstStyle/>
-          <a:p>
-            <a:pPr algn="l"/>
+            <a:off x="6766560" y="1737360"/>
+            <a:ext cx="4800600" cy="4297680"/>
+          </a:xfrm>
+          <a:prstGeom prst="rect">
+            <a:avLst/>
+          </a:prstGeom>
+          <a:noFill/>
+        </p:spPr>
+        <p:txBody>
+          <a:bodyPr wrap="square">
+            <a:spAutoFit/>
+          </a:bodyPr>
+          <a:lstStyle/>
+          <a:p>
+            <a:pPr>
+              <a:spcAft>
+                <a:spcPts val="300"/>
+              </a:spcAft>
+            </a:pPr>
+            <a:r>
+              <a:rPr sz="1400" b="1">
+                <a:solidFill>
+                  <a:srgbClr val="7CDA6A"/>
+                </a:solidFill>
+                <a:latin typeface="Consolas"/>
+              </a:rPr>
+              <a:t>disass main in ch_mov.</a:t>
+            </a:r>
+          </a:p>
+          <a:p>
+            <a:pPr>
+              <a:spcAft>
+                <a:spcPts val="300"/>
+              </a:spcAft>
+            </a:pPr>
             <a:r>
               <a:rPr sz="1600" b="0">
                 <a:solidFill>
@@ -10669,11 +10689,135 @@
                 </a:solidFill>
                 <a:latin typeface="Calibri"/>
               </a:rPr>
-              <a:t>Same pattern, different numbers.
-Stores a value to a local, then loads it.
-break check
-  eax = ?
-  ecx = ?</a:t>
+              <a:t> </a:t>
+            </a:r>
+          </a:p>
+          <a:p>
+            <a:pPr>
+              <a:spcAft>
+                <a:spcPts val="300"/>
+              </a:spcAft>
+            </a:pPr>
+            <a:r>
+              <a:rPr sz="1400" b="1">
+                <a:solidFill>
+                  <a:srgbClr val="7CDA6A"/>
+                </a:solidFill>
+                <a:latin typeface="Consolas"/>
+              </a:rPr>
+              <a:t>After  mov eax, ebx</a:t>
+            </a:r>
+          </a:p>
+          <a:p>
+            <a:pPr>
+              <a:spcAft>
+                <a:spcPts val="300"/>
+              </a:spcAft>
+            </a:pPr>
+            <a:r>
+              <a:rPr sz="1600" b="0">
+                <a:solidFill>
+                  <a:srgbClr val="F2F2F2"/>
+                </a:solidFill>
+                <a:latin typeface="Calibri"/>
+              </a:rPr>
+              <a:t>  eax = ?</a:t>
+            </a:r>
+          </a:p>
+          <a:p>
+            <a:pPr>
+              <a:spcAft>
+                <a:spcPts val="300"/>
+              </a:spcAft>
+            </a:pPr>
+            <a:r>
+              <a:rPr sz="1600" b="0">
+                <a:solidFill>
+                  <a:srgbClr val="F2F2F2"/>
+                </a:solidFill>
+                <a:latin typeface="Calibri"/>
+              </a:rPr>
+              <a:t> </a:t>
+            </a:r>
+          </a:p>
+          <a:p>
+            <a:pPr>
+              <a:spcAft>
+                <a:spcPts val="300"/>
+              </a:spcAft>
+            </a:pPr>
+            <a:r>
+              <a:rPr sz="1400" b="1">
+                <a:solidFill>
+                  <a:srgbClr val="7CDA6A"/>
+                </a:solidFill>
+                <a:latin typeface="Consolas"/>
+              </a:rPr>
+              <a:t>After  mov ecx, [ebp-4]</a:t>
+            </a:r>
+          </a:p>
+          <a:p>
+            <a:pPr>
+              <a:spcAft>
+                <a:spcPts val="300"/>
+              </a:spcAft>
+            </a:pPr>
+            <a:r>
+              <a:rPr sz="1600" b="0">
+                <a:solidFill>
+                  <a:srgbClr val="F2F2F2"/>
+                </a:solidFill>
+                <a:latin typeface="Calibri"/>
+              </a:rPr>
+              <a:t>  ecx = ?</a:t>
+            </a:r>
+          </a:p>
+          <a:p>
+            <a:pPr>
+              <a:spcAft>
+                <a:spcPts val="300"/>
+              </a:spcAft>
+            </a:pPr>
+            <a:r>
+              <a:rPr sz="1600" b="0">
+                <a:solidFill>
+                  <a:srgbClr val="F2F2F2"/>
+                </a:solidFill>
+                <a:latin typeface="Calibri"/>
+              </a:rPr>
+              <a:t> </a:t>
+            </a:r>
+          </a:p>
+          <a:p>
+            <a:pPr>
+              <a:spcAft>
+                <a:spcPts val="300"/>
+              </a:spcAft>
+            </a:pPr>
+            <a:r>
+              <a:rPr sz="1400" b="1">
+                <a:solidFill>
+                  <a:srgbClr val="7CDA6A"/>
+                </a:solidFill>
+                <a:latin typeface="Consolas"/>
+              </a:rPr>
+              <a:t>After  mov eax, ecx</a:t>
+            </a:r>
+          </a:p>
+          <a:p>
+            <a:pPr>
+              <a:spcAft>
+                <a:spcPts val="300"/>
+              </a:spcAft>
+            </a:pPr>
+            <a:r>
+              <a:rPr sz="1600" b="0">
+                <a:solidFill>
+                  <a:srgbClr val="F2F2F2"/>
+                </a:solidFill>
+                <a:latin typeface="Calibri"/>
+              </a:rPr>
+              <a:t>  eax = ?</a:t>
             </a:r>
           </a:p>
         </p:txBody>
@@ -11595,21 +11739,41 @@
         </p:nvSpPr>
         <p:spPr>
           <a:xfrm>
-            <a:off x="6766560" y="1783080"/>
-            <a:ext cx="4800600" cy="4206240"/>
-          </a:xfrm>
-          <a:prstGeom prst="rect">
-            <a:avLst/>
-          </a:prstGeom>
-          <a:noFill/>
-        </p:spPr>
-        <p:txBody>
-          <a:bodyPr wrap="square">
-            <a:spAutoFit/>
-          </a:bodyPr>
-          <a:lstStyle/>
-          <a:p>
-            <a:pPr algn="l"/>
+            <a:off x="6766560" y="1737360"/>
+            <a:ext cx="4800600" cy="4297680"/>
+          </a:xfrm>
+          <a:prstGeom prst="rect">
+            <a:avLst/>
+          </a:prstGeom>
+          <a:noFill/>
+        </p:spPr>
+        <p:txBody>
+          <a:bodyPr wrap="square">
+            <a:spAutoFit/>
+          </a:bodyPr>
+          <a:lstStyle/>
+          <a:p>
+            <a:pPr>
+              <a:spcAft>
+                <a:spcPts val="300"/>
+              </a:spcAft>
+            </a:pPr>
+            <a:r>
+              <a:rPr sz="1400" b="1">
+                <a:solidFill>
+                  <a:srgbClr val="7CDA6A"/>
+                </a:solidFill>
+                <a:latin typeface="Consolas"/>
+              </a:rPr>
+              <a:t>disass main in ch_arith.</a:t>
+            </a:r>
+          </a:p>
+          <a:p>
+            <a:pPr>
+              <a:spcAft>
+                <a:spcPts val="300"/>
+              </a:spcAft>
+            </a:pPr>
             <a:r>
               <a:rPr sz="1600" b="0">
                 <a:solidFill>
@@ -11617,9 +11781,135 @@
                 </a:solidFill>
                 <a:latin typeface="Calibri"/>
               </a:rPr>
-              <a:t>Same ops, different start value and an extra inc.
-break check
-  eax = ?</a:t>
+              <a:t> </a:t>
+            </a:r>
+          </a:p>
+          <a:p>
+            <a:pPr>
+              <a:spcAft>
+                <a:spcPts val="300"/>
+              </a:spcAft>
+            </a:pPr>
+            <a:r>
+              <a:rPr sz="1400" b="1">
+                <a:solidFill>
+                  <a:srgbClr val="7CDA6A"/>
+                </a:solidFill>
+                <a:latin typeface="Consolas"/>
+              </a:rPr>
+              <a:t>After  add eax, 7</a:t>
+            </a:r>
+          </a:p>
+          <a:p>
+            <a:pPr>
+              <a:spcAft>
+                <a:spcPts val="300"/>
+              </a:spcAft>
+            </a:pPr>
+            <a:r>
+              <a:rPr sz="1600" b="0">
+                <a:solidFill>
+                  <a:srgbClr val="F2F2F2"/>
+                </a:solidFill>
+                <a:latin typeface="Calibri"/>
+              </a:rPr>
+              <a:t>  eax = ?</a:t>
+            </a:r>
+          </a:p>
+          <a:p>
+            <a:pPr>
+              <a:spcAft>
+                <a:spcPts val="300"/>
+              </a:spcAft>
+            </a:pPr>
+            <a:r>
+              <a:rPr sz="1600" b="0">
+                <a:solidFill>
+                  <a:srgbClr val="F2F2F2"/>
+                </a:solidFill>
+                <a:latin typeface="Calibri"/>
+              </a:rPr>
+              <a:t> </a:t>
+            </a:r>
+          </a:p>
+          <a:p>
+            <a:pPr>
+              <a:spcAft>
+                <a:spcPts val="300"/>
+              </a:spcAft>
+            </a:pPr>
+            <a:r>
+              <a:rPr sz="1400" b="1">
+                <a:solidFill>
+                  <a:srgbClr val="7CDA6A"/>
+                </a:solidFill>
+                <a:latin typeface="Consolas"/>
+              </a:rPr>
+              <a:t>After the two inc and one dec</a:t>
+            </a:r>
+          </a:p>
+          <a:p>
+            <a:pPr>
+              <a:spcAft>
+                <a:spcPts val="300"/>
+              </a:spcAft>
+            </a:pPr>
+            <a:r>
+              <a:rPr sz="1600" b="0">
+                <a:solidFill>
+                  <a:srgbClr val="F2F2F2"/>
+                </a:solidFill>
+                <a:latin typeface="Calibri"/>
+              </a:rPr>
+              <a:t>  eax = ?</a:t>
+            </a:r>
+          </a:p>
+          <a:p>
+            <a:pPr>
+              <a:spcAft>
+                <a:spcPts val="300"/>
+              </a:spcAft>
+            </a:pPr>
+            <a:r>
+              <a:rPr sz="1600" b="0">
+                <a:solidFill>
+                  <a:srgbClr val="F2F2F2"/>
+                </a:solidFill>
+                <a:latin typeface="Calibri"/>
+              </a:rPr>
+              <a:t> </a:t>
+            </a:r>
+          </a:p>
+          <a:p>
+            <a:pPr>
+              <a:spcAft>
+                <a:spcPts val="300"/>
+              </a:spcAft>
+            </a:pPr>
+            <a:r>
+              <a:rPr sz="1400" b="1">
+                <a:solidFill>
+                  <a:srgbClr val="7CDA6A"/>
+                </a:solidFill>
+                <a:latin typeface="Consolas"/>
+              </a:rPr>
+              <a:t>At check, after  add eax, ebx</a:t>
+            </a:r>
+          </a:p>
+          <a:p>
+            <a:pPr>
+              <a:spcAft>
+                <a:spcPts val="300"/>
+              </a:spcAft>
+            </a:pPr>
+            <a:r>
+              <a:rPr sz="1600" b="0">
+                <a:solidFill>
+                  <a:srgbClr val="F2F2F2"/>
+                </a:solidFill>
+                <a:latin typeface="Calibri"/>
+              </a:rPr>
+              <a:t>  eax = ?</a:t>
             </a:r>
           </a:p>
         </p:txBody>
@@ -13015,21 +13305,41 @@
         </p:nvSpPr>
         <p:spPr>
           <a:xfrm>
-            <a:off x="6766560" y="1783080"/>
-            <a:ext cx="4800600" cy="4206240"/>
-          </a:xfrm>
-          <a:prstGeom prst="rect">
-            <a:avLst/>
-          </a:prstGeom>
-          <a:noFill/>
-        </p:spPr>
-        <p:txBody>
-          <a:bodyPr wrap="square">
-            <a:spAutoFit/>
-          </a:bodyPr>
-          <a:lstStyle/>
-          <a:p>
-            <a:pPr algn="l"/>
+            <a:off x="6766560" y="1737360"/>
+            <a:ext cx="4800600" cy="4297680"/>
+          </a:xfrm>
+          <a:prstGeom prst="rect">
+            <a:avLst/>
+          </a:prstGeom>
+          <a:noFill/>
+        </p:spPr>
+        <p:txBody>
+          <a:bodyPr wrap="square">
+            <a:spAutoFit/>
+          </a:bodyPr>
+          <a:lstStyle/>
+          <a:p>
+            <a:pPr>
+              <a:spcAft>
+                <a:spcPts val="300"/>
+              </a:spcAft>
+            </a:pPr>
+            <a:r>
+              <a:rPr sz="1400" b="1">
+                <a:solidFill>
+                  <a:srgbClr val="7CDA6A"/>
+                </a:solidFill>
+                <a:latin typeface="Consolas"/>
+              </a:rPr>
+              <a:t>disass main in ch_xor.</a:t>
+            </a:r>
+          </a:p>
+          <a:p>
+            <a:pPr>
+              <a:spcAft>
+                <a:spcPts val="300"/>
+              </a:spcAft>
+            </a:pPr>
             <a:r>
               <a:rPr sz="1600" b="0">
                 <a:solidFill>
@@ -13037,12 +13347,199 @@
                 </a:solidFill>
                 <a:latin typeface="Calibri"/>
               </a:rPr>
-              <a:t>xor eax with a value, then xor ebx with itself, then xor those together.
-break check
-  eax = ?
-  ZF set?
-print ($eflags &amp; 0x40)
-non-zero = ZF set</a:t>
+              <a:t> </a:t>
+            </a:r>
+          </a:p>
+          <a:p>
+            <a:pPr>
+              <a:spcAft>
+                <a:spcPts val="300"/>
+              </a:spcAft>
+            </a:pPr>
+            <a:r>
+              <a:rPr sz="1400" b="1">
+                <a:solidFill>
+                  <a:srgbClr val="7CDA6A"/>
+                </a:solidFill>
+                <a:latin typeface="Consolas"/>
+              </a:rPr>
+              <a:t>After  xor eax, 0x12</a:t>
+            </a:r>
+          </a:p>
+          <a:p>
+            <a:pPr>
+              <a:spcAft>
+                <a:spcPts val="300"/>
+              </a:spcAft>
+            </a:pPr>
+            <a:r>
+              <a:rPr sz="1600" b="0">
+                <a:solidFill>
+                  <a:srgbClr val="F2F2F2"/>
+                </a:solidFill>
+                <a:latin typeface="Calibri"/>
+              </a:rPr>
+              <a:t>  eax = ?</a:t>
+            </a:r>
+          </a:p>
+          <a:p>
+            <a:pPr>
+              <a:spcAft>
+                <a:spcPts val="300"/>
+              </a:spcAft>
+            </a:pPr>
+            <a:r>
+              <a:rPr sz="1600" b="0">
+                <a:solidFill>
+                  <a:srgbClr val="F2F2F2"/>
+                </a:solidFill>
+                <a:latin typeface="Calibri"/>
+              </a:rPr>
+              <a:t> </a:t>
+            </a:r>
+          </a:p>
+          <a:p>
+            <a:pPr>
+              <a:spcAft>
+                <a:spcPts val="300"/>
+              </a:spcAft>
+            </a:pPr>
+            <a:r>
+              <a:rPr sz="1400" b="1">
+                <a:solidFill>
+                  <a:srgbClr val="7CDA6A"/>
+                </a:solidFill>
+                <a:latin typeface="Consolas"/>
+              </a:rPr>
+              <a:t>After  xor ebx, 0xAA</a:t>
+            </a:r>
+          </a:p>
+          <a:p>
+            <a:pPr>
+              <a:spcAft>
+                <a:spcPts val="300"/>
+              </a:spcAft>
+            </a:pPr>
+            <a:r>
+              <a:rPr sz="1600" b="0">
+                <a:solidFill>
+                  <a:srgbClr val="F2F2F2"/>
+                </a:solidFill>
+                <a:latin typeface="Calibri"/>
+              </a:rPr>
+              <a:t>  ebx = ?</a:t>
+            </a:r>
+          </a:p>
+          <a:p>
+            <a:pPr>
+              <a:spcAft>
+                <a:spcPts val="300"/>
+              </a:spcAft>
+            </a:pPr>
+            <a:r>
+              <a:rPr sz="1600" b="0">
+                <a:solidFill>
+                  <a:srgbClr val="F2F2F2"/>
+                </a:solidFill>
+                <a:latin typeface="Calibri"/>
+              </a:rPr>
+              <a:t>  ZF set?</a:t>
+            </a:r>
+          </a:p>
+          <a:p>
+            <a:pPr>
+              <a:spcAft>
+                <a:spcPts val="300"/>
+              </a:spcAft>
+            </a:pPr>
+            <a:r>
+              <a:rPr sz="1600" b="0">
+                <a:solidFill>
+                  <a:srgbClr val="F2F2F2"/>
+                </a:solidFill>
+                <a:latin typeface="Calibri"/>
+              </a:rPr>
+              <a:t> </a:t>
+            </a:r>
+          </a:p>
+          <a:p>
+            <a:pPr>
+              <a:spcAft>
+                <a:spcPts val="300"/>
+              </a:spcAft>
+            </a:pPr>
+            <a:r>
+              <a:rPr sz="1400" b="1">
+                <a:solidFill>
+                  <a:srgbClr val="7CDA6A"/>
+                </a:solidFill>
+                <a:latin typeface="Consolas"/>
+              </a:rPr>
+              <a:t>At check, after  xor eax, ebx</a:t>
+            </a:r>
+          </a:p>
+          <a:p>
+            <a:pPr>
+              <a:spcAft>
+                <a:spcPts val="300"/>
+              </a:spcAft>
+            </a:pPr>
+            <a:r>
+              <a:rPr sz="1600" b="0">
+                <a:solidFill>
+                  <a:srgbClr val="F2F2F2"/>
+                </a:solidFill>
+                <a:latin typeface="Calibri"/>
+              </a:rPr>
+              <a:t>  eax = ?</a:t>
+            </a:r>
+          </a:p>
+          <a:p>
+            <a:pPr>
+              <a:spcAft>
+                <a:spcPts val="300"/>
+              </a:spcAft>
+            </a:pPr>
+            <a:r>
+              <a:rPr sz="1600" b="0">
+                <a:solidFill>
+                  <a:srgbClr val="F2F2F2"/>
+                </a:solidFill>
+                <a:latin typeface="Calibri"/>
+              </a:rPr>
+              <a:t>  ZF set?</a:t>
+            </a:r>
+          </a:p>
+          <a:p>
+            <a:pPr>
+              <a:spcAft>
+                <a:spcPts val="300"/>
+              </a:spcAft>
+            </a:pPr>
+            <a:r>
+              <a:rPr sz="1600" b="0">
+                <a:solidFill>
+                  <a:srgbClr val="F2F2F2"/>
+                </a:solidFill>
+                <a:latin typeface="Calibri"/>
+              </a:rPr>
+              <a:t> </a:t>
+            </a:r>
+          </a:p>
+          <a:p>
+            <a:pPr>
+              <a:spcAft>
+                <a:spcPts val="300"/>
+              </a:spcAft>
+            </a:pPr>
+            <a:r>
+              <a:rPr sz="1400" b="1">
+                <a:solidFill>
+                  <a:srgbClr val="7CDA6A"/>
+                </a:solidFill>
+                <a:latin typeface="Consolas"/>
+              </a:rPr>
+              <a:t>print ($eflags &amp; 0x40)   non-zero = set</a:t>
             </a:r>
           </a:p>
         </p:txBody>
@@ -13964,21 +14461,41 @@
         </p:nvSpPr>
         <p:spPr>
           <a:xfrm>
-            <a:off x="6766560" y="1783080"/>
-            <a:ext cx="4800600" cy="4206240"/>
-          </a:xfrm>
-          <a:prstGeom prst="rect">
-            <a:avLst/>
-          </a:prstGeom>
-          <a:noFill/>
-        </p:spPr>
-        <p:txBody>
-          <a:bodyPr wrap="square">
-            <a:spAutoFit/>
-          </a:bodyPr>
-          <a:lstStyle/>
-          <a:p>
-            <a:pPr algn="l"/>
+            <a:off x="6766560" y="1737360"/>
+            <a:ext cx="4800600" cy="4297680"/>
+          </a:xfrm>
+          <a:prstGeom prst="rect">
+            <a:avLst/>
+          </a:prstGeom>
+          <a:noFill/>
+        </p:spPr>
+        <p:txBody>
+          <a:bodyPr wrap="square">
+            <a:spAutoFit/>
+          </a:bodyPr>
+          <a:lstStyle/>
+          <a:p>
+            <a:pPr>
+              <a:spcAft>
+                <a:spcPts val="300"/>
+              </a:spcAft>
+            </a:pPr>
+            <a:r>
+              <a:rPr sz="1400" b="1">
+                <a:solidFill>
+                  <a:srgbClr val="7CDA6A"/>
+                </a:solidFill>
+                <a:latin typeface="Consolas"/>
+              </a:rPr>
+              <a:t>disass main in ch_jmp.</a:t>
+            </a:r>
+          </a:p>
+          <a:p>
+            <a:pPr>
+              <a:spcAft>
+                <a:spcPts val="300"/>
+              </a:spcAft>
+            </a:pPr>
             <a:r>
               <a:rPr sz="1600" b="0">
                 <a:solidFill>
@@ -13986,10 +14503,135 @@
                 </a:solidFill>
                 <a:latin typeface="Calibri"/>
               </a:rPr>
-              <a:t>Compares two numbers, takes je or jne.
-break check
-  eax = ?
-  equal path or not_equal?</a:t>
+              <a:t> </a:t>
+            </a:r>
+          </a:p>
+          <a:p>
+            <a:pPr>
+              <a:spcAft>
+                <a:spcPts val="300"/>
+              </a:spcAft>
+            </a:pPr>
+            <a:r>
+              <a:rPr sz="1400" b="1">
+                <a:solidFill>
+                  <a:srgbClr val="7CDA6A"/>
+                </a:solidFill>
+                <a:latin typeface="Consolas"/>
+              </a:rPr>
+              <a:t>After  cmp eax, ebx</a:t>
+            </a:r>
+          </a:p>
+          <a:p>
+            <a:pPr>
+              <a:spcAft>
+                <a:spcPts val="300"/>
+              </a:spcAft>
+            </a:pPr>
+            <a:r>
+              <a:rPr sz="1600" b="0">
+                <a:solidFill>
+                  <a:srgbClr val="F2F2F2"/>
+                </a:solidFill>
+                <a:latin typeface="Calibri"/>
+              </a:rPr>
+              <a:t>  equal or not?</a:t>
+            </a:r>
+          </a:p>
+          <a:p>
+            <a:pPr>
+              <a:spcAft>
+                <a:spcPts val="300"/>
+              </a:spcAft>
+            </a:pPr>
+            <a:r>
+              <a:rPr sz="1600" b="0">
+                <a:solidFill>
+                  <a:srgbClr val="F2F2F2"/>
+                </a:solidFill>
+                <a:latin typeface="Calibri"/>
+              </a:rPr>
+              <a:t> </a:t>
+            </a:r>
+          </a:p>
+          <a:p>
+            <a:pPr>
+              <a:spcAft>
+                <a:spcPts val="300"/>
+              </a:spcAft>
+            </a:pPr>
+            <a:r>
+              <a:rPr sz="1400" b="1">
+                <a:solidFill>
+                  <a:srgbClr val="7CDA6A"/>
+                </a:solidFill>
+                <a:latin typeface="Consolas"/>
+              </a:rPr>
+              <a:t>Does  je  run, or  jne?</a:t>
+            </a:r>
+          </a:p>
+          <a:p>
+            <a:pPr>
+              <a:spcAft>
+                <a:spcPts val="300"/>
+              </a:spcAft>
+            </a:pPr>
+            <a:r>
+              <a:rPr sz="1600" b="0">
+                <a:solidFill>
+                  <a:srgbClr val="F2F2F2"/>
+                </a:solidFill>
+                <a:latin typeface="Calibri"/>
+              </a:rPr>
+              <a:t> </a:t>
+            </a:r>
+          </a:p>
+          <a:p>
+            <a:pPr>
+              <a:spcAft>
+                <a:spcPts val="300"/>
+              </a:spcAft>
+            </a:pPr>
+            <a:r>
+              <a:rPr sz="1400" b="1">
+                <a:solidFill>
+                  <a:srgbClr val="7CDA6A"/>
+                </a:solidFill>
+                <a:latin typeface="Consolas"/>
+              </a:rPr>
+              <a:t>At check</a:t>
+            </a:r>
+          </a:p>
+          <a:p>
+            <a:pPr>
+              <a:spcAft>
+                <a:spcPts val="300"/>
+              </a:spcAft>
+            </a:pPr>
+            <a:r>
+              <a:rPr sz="1600" b="0">
+                <a:solidFill>
+                  <a:srgbClr val="F2F2F2"/>
+                </a:solidFill>
+                <a:latin typeface="Calibri"/>
+              </a:rPr>
+              <a:t>  eax = ?</a:t>
+            </a:r>
+          </a:p>
+          <a:p>
+            <a:pPr>
+              <a:spcAft>
+                <a:spcPts val="300"/>
+              </a:spcAft>
+            </a:pPr>
+            <a:r>
+              <a:rPr sz="1600" b="0">
+                <a:solidFill>
+                  <a:srgbClr val="F2F2F2"/>
+                </a:solidFill>
+                <a:latin typeface="Calibri"/>
+              </a:rPr>
+              <a:t>  which label ran: equal or not_equal?</a:t>
             </a:r>
           </a:p>
         </p:txBody>
@@ -14911,21 +15553,41 @@
         </p:nvSpPr>
         <p:spPr>
           <a:xfrm>
-            <a:off x="6766560" y="1783080"/>
-            <a:ext cx="4800600" cy="4206240"/>
-          </a:xfrm>
-          <a:prstGeom prst="rect">
-            <a:avLst/>
-          </a:prstGeom>
-          <a:noFill/>
-        </p:spPr>
-        <p:txBody>
-          <a:bodyPr wrap="square">
-            <a:spAutoFit/>
-          </a:bodyPr>
-          <a:lstStyle/>
-          <a:p>
-            <a:pPr algn="l"/>
+            <a:off x="6766560" y="1737360"/>
+            <a:ext cx="4800600" cy="4297680"/>
+          </a:xfrm>
+          <a:prstGeom prst="rect">
+            <a:avLst/>
+          </a:prstGeom>
+          <a:noFill/>
+        </p:spPr>
+        <p:txBody>
+          <a:bodyPr wrap="square">
+            <a:spAutoFit/>
+          </a:bodyPr>
+          <a:lstStyle/>
+          <a:p>
+            <a:pPr>
+              <a:spcAft>
+                <a:spcPts val="300"/>
+              </a:spcAft>
+            </a:pPr>
+            <a:r>
+              <a:rPr sz="1400" b="1">
+                <a:solidFill>
+                  <a:srgbClr val="7CDA6A"/>
+                </a:solidFill>
+                <a:latin typeface="Consolas"/>
+              </a:rPr>
+              <a:t>disass main in ch_stack.</a:t>
+            </a:r>
+          </a:p>
+          <a:p>
+            <a:pPr>
+              <a:spcAft>
+                <a:spcPts val="300"/>
+              </a:spcAft>
+            </a:pPr>
             <a:r>
               <a:rPr sz="1600" b="0">
                 <a:solidFill>
@@ -14933,13 +15595,151 @@
                 </a:solidFill>
                 <a:latin typeface="Calibri"/>
               </a:rPr>
-              <a:t>Two pushes, then two pops. Last in, first out.
-break before_pop
-  [esp] = ?
-  [esp+4] = ?
-break check
-  ecx = ?
-  edx = ?</a:t>
+              <a:t> </a:t>
+            </a:r>
+          </a:p>
+          <a:p>
+            <a:pPr>
+              <a:spcAft>
+                <a:spcPts val="300"/>
+              </a:spcAft>
+            </a:pPr>
+            <a:r>
+              <a:rPr sz="1400" b="1">
+                <a:solidFill>
+                  <a:srgbClr val="7CDA6A"/>
+                </a:solidFill>
+                <a:latin typeface="Consolas"/>
+              </a:rPr>
+              <a:t>At before_pop (both pushed, nothing popped yet)</a:t>
+            </a:r>
+          </a:p>
+          <a:p>
+            <a:pPr>
+              <a:spcAft>
+                <a:spcPts val="300"/>
+              </a:spcAft>
+            </a:pPr>
+            <a:r>
+              <a:rPr sz="1600" b="0">
+                <a:solidFill>
+                  <a:srgbClr val="F2F2F2"/>
+                </a:solidFill>
+                <a:latin typeface="Calibri"/>
+              </a:rPr>
+              <a:t>  [esp] = ?</a:t>
+            </a:r>
+          </a:p>
+          <a:p>
+            <a:pPr>
+              <a:spcAft>
+                <a:spcPts val="300"/>
+              </a:spcAft>
+            </a:pPr>
+            <a:r>
+              <a:rPr sz="1600" b="0">
+                <a:solidFill>
+                  <a:srgbClr val="F2F2F2"/>
+                </a:solidFill>
+                <a:latin typeface="Calibri"/>
+              </a:rPr>
+              <a:t>  [esp+4] = ?</a:t>
+            </a:r>
+          </a:p>
+          <a:p>
+            <a:pPr>
+              <a:spcAft>
+                <a:spcPts val="300"/>
+              </a:spcAft>
+            </a:pPr>
+            <a:r>
+              <a:rPr sz="1600" b="0">
+                <a:solidFill>
+                  <a:srgbClr val="F2F2F2"/>
+                </a:solidFill>
+                <a:latin typeface="Calibri"/>
+              </a:rPr>
+              <a:t> </a:t>
+            </a:r>
+          </a:p>
+          <a:p>
+            <a:pPr>
+              <a:spcAft>
+                <a:spcPts val="300"/>
+              </a:spcAft>
+            </a:pPr>
+            <a:r>
+              <a:rPr sz="1400" b="1">
+                <a:solidFill>
+                  <a:srgbClr val="7CDA6A"/>
+                </a:solidFill>
+                <a:latin typeface="Consolas"/>
+              </a:rPr>
+              <a:t>After  pop ecx</a:t>
+            </a:r>
+          </a:p>
+          <a:p>
+            <a:pPr>
+              <a:spcAft>
+                <a:spcPts val="300"/>
+              </a:spcAft>
+            </a:pPr>
+            <a:r>
+              <a:rPr sz="1600" b="0">
+                <a:solidFill>
+                  <a:srgbClr val="F2F2F2"/>
+                </a:solidFill>
+                <a:latin typeface="Calibri"/>
+              </a:rPr>
+              <a:t>  ecx = ?</a:t>
+            </a:r>
+          </a:p>
+          <a:p>
+            <a:pPr>
+              <a:spcAft>
+                <a:spcPts val="300"/>
+              </a:spcAft>
+            </a:pPr>
+            <a:r>
+              <a:rPr sz="1600" b="0">
+                <a:solidFill>
+                  <a:srgbClr val="F2F2F2"/>
+                </a:solidFill>
+                <a:latin typeface="Calibri"/>
+              </a:rPr>
+              <a:t> </a:t>
+            </a:r>
+          </a:p>
+          <a:p>
+            <a:pPr>
+              <a:spcAft>
+                <a:spcPts val="300"/>
+              </a:spcAft>
+            </a:pPr>
+            <a:r>
+              <a:rPr sz="1400" b="1">
+                <a:solidFill>
+                  <a:srgbClr val="7CDA6A"/>
+                </a:solidFill>
+                <a:latin typeface="Consolas"/>
+              </a:rPr>
+              <a:t>After  pop edx</a:t>
+            </a:r>
+          </a:p>
+          <a:p>
+            <a:pPr>
+              <a:spcAft>
+                <a:spcPts val="300"/>
+              </a:spcAft>
+            </a:pPr>
+            <a:r>
+              <a:rPr sz="1600" b="0">
+                <a:solidFill>
+                  <a:srgbClr val="F2F2F2"/>
+                </a:solidFill>
+                <a:latin typeface="Calibri"/>
+              </a:rPr>
+              <a:t>  edx = ?</a:t>
             </a:r>
           </a:p>
         </p:txBody>
@@ -15861,21 +16661,41 @@
         </p:nvSpPr>
         <p:spPr>
           <a:xfrm>
-            <a:off x="6766560" y="1783080"/>
-            <a:ext cx="4800600" cy="4206240"/>
-          </a:xfrm>
-          <a:prstGeom prst="rect">
-            <a:avLst/>
-          </a:prstGeom>
-          <a:noFill/>
-        </p:spPr>
-        <p:txBody>
-          <a:bodyPr wrap="square">
-            <a:spAutoFit/>
-          </a:bodyPr>
-          <a:lstStyle/>
-          <a:p>
-            <a:pPr algn="l"/>
+            <a:off x="6766560" y="1737360"/>
+            <a:ext cx="4800600" cy="4297680"/>
+          </a:xfrm>
+          <a:prstGeom prst="rect">
+            <a:avLst/>
+          </a:prstGeom>
+          <a:noFill/>
+        </p:spPr>
+        <p:txBody>
+          <a:bodyPr wrap="square">
+            <a:spAutoFit/>
+          </a:bodyPr>
+          <a:lstStyle/>
+          <a:p>
+            <a:pPr>
+              <a:spcAft>
+                <a:spcPts val="300"/>
+              </a:spcAft>
+            </a:pPr>
+            <a:r>
+              <a:rPr sz="1400" b="1">
+                <a:solidFill>
+                  <a:srgbClr val="7CDA6A"/>
+                </a:solidFill>
+                <a:latin typeface="Consolas"/>
+              </a:rPr>
+              <a:t>disass main and triple in ch_call.</a:t>
+            </a:r>
+          </a:p>
+          <a:p>
+            <a:pPr>
+              <a:spcAft>
+                <a:spcPts val="300"/>
+              </a:spcAft>
+            </a:pPr>
             <a:r>
               <a:rPr sz="1600" b="0">
                 <a:solidFill>
@@ -15883,9 +16703,71 @@
                 </a:solidFill>
                 <a:latin typeface="Calibri"/>
               </a:rPr>
-              <a:t>Calls triple instead of add_one. Different argument.
-break check  (after call returns)
-  eax = ?</a:t>
+              <a:t> </a:t>
+            </a:r>
+          </a:p>
+          <a:p>
+            <a:pPr>
+              <a:spcAft>
+                <a:spcPts val="300"/>
+              </a:spcAft>
+            </a:pPr>
+            <a:r>
+              <a:rPr sz="1400" b="1">
+                <a:solidFill>
+                  <a:srgbClr val="7CDA6A"/>
+                </a:solidFill>
+                <a:latin typeface="Consolas"/>
+              </a:rPr>
+              <a:t>What does triple do with [ebp+8]?</a:t>
+            </a:r>
+          </a:p>
+          <a:p>
+            <a:pPr>
+              <a:spcAft>
+                <a:spcPts val="300"/>
+              </a:spcAft>
+            </a:pPr>
+            <a:r>
+              <a:rPr sz="1600" b="0">
+                <a:solidFill>
+                  <a:srgbClr val="F2F2F2"/>
+                </a:solidFill>
+                <a:latin typeface="Calibri"/>
+              </a:rPr>
+              <a:t> </a:t>
+            </a:r>
+          </a:p>
+          <a:p>
+            <a:pPr>
+              <a:spcAft>
+                <a:spcPts val="300"/>
+              </a:spcAft>
+            </a:pPr>
+            <a:r>
+              <a:rPr sz="1400" b="1">
+                <a:solidFill>
+                  <a:srgbClr val="7CDA6A"/>
+                </a:solidFill>
+                <a:latin typeface="Consolas"/>
+              </a:rPr>
+              <a:t>After  call triple  returns (label check)</a:t>
+            </a:r>
+          </a:p>
+          <a:p>
+            <a:pPr>
+              <a:spcAft>
+                <a:spcPts val="300"/>
+              </a:spcAft>
+            </a:pPr>
+            <a:r>
+              <a:rPr sz="1600" b="0">
+                <a:solidFill>
+                  <a:srgbClr val="F2F2F2"/>
+                </a:solidFill>
+                <a:latin typeface="Calibri"/>
+              </a:rPr>
+              <a:t>  eax = ?</a:t>
             </a:r>
           </a:p>
         </p:txBody>

</xml_diff>

<commit_message>
Add Java 21 to install steps and refresh the deck.
Co-authored-by: Cursor <cursoragent@cursor.com>
</commit_message>
<xml_diff>
--- a/Reverse Engineering 101.pptx
+++ b/Reverse Engineering 101.pptx
@@ -3424,7 +3424,6 @@
           <a:lstStyle/>
           <a:p>
             <a:pPr algn="ctr"/>
-            <a:endParaRPr/>
           </a:p>
         </p:txBody>
       </p:sp>
@@ -3459,6 +3458,41 @@
                 <a:latin typeface="Calibri"/>
               </a:rPr>
               <a:t>Install GDB + GEF</a:t>
+            </a:r>
+          </a:p>
+        </p:txBody>
+      </p:sp>
+      <p:sp>
+        <p:nvSpPr>
+          <p:cNvPr id="4" name="TextBox 3"/>
+          <p:cNvSpPr txBox="1"/>
+          <p:nvPr/>
+        </p:nvSpPr>
+        <p:spPr>
+          <a:xfrm>
+            <a:off x="457200" y="960120"/>
+            <a:ext cx="11247120" cy="365760"/>
+          </a:xfrm>
+          <a:prstGeom prst="rect">
+            <a:avLst/>
+          </a:prstGeom>
+          <a:noFill/>
+        </p:spPr>
+        <p:txBody>
+          <a:bodyPr wrap="square">
+            <a:spAutoFit/>
+          </a:bodyPr>
+          <a:lstStyle/>
+          <a:p>
+            <a:pPr algn="l"/>
+            <a:r>
+              <a:rPr sz="1700" b="0">
+                <a:solidFill>
+                  <a:srgbClr val="B0B0B0"/>
+                </a:solidFill>
+                <a:latin typeface="Calibri"/>
+              </a:rPr>
+              <a:t>Debian / Ubuntu / WSL. New terminal after GEF so it loads.</a:t>
             </a:r>
           </a:p>
         </p:txBody>
@@ -3504,7 +3538,6 @@
           <a:lstStyle/>
           <a:p>
             <a:pPr algn="ctr"/>
-            <a:endParaRPr/>
           </a:p>
         </p:txBody>
       </p:sp>
@@ -3516,8 +3549,8 @@
         </p:nvSpPr>
         <p:spPr>
           <a:xfrm>
-            <a:off x="685800" y="1600200"/>
-            <a:ext cx="10789920" cy="3657411"/>
+            <a:off x="685800" y="1572768"/>
+            <a:ext cx="10789920" cy="4617720"/>
           </a:xfrm>
           <a:prstGeom prst="rect">
             <a:avLst/>
@@ -3532,244 +3565,130 @@
           <a:p>
             <a:pPr>
               <a:spcAft>
-                <a:spcPts val="1000"/>
+                <a:spcPts val="800"/>
               </a:spcAft>
             </a:pPr>
-            <a:br>
-              <a:rPr lang="en-IN" sz="2000" b="1" dirty="0">
+            <a:r>
+              <a:rPr sz="2000" b="1">
                 <a:solidFill>
                   <a:srgbClr val="7CDA6A"/>
                 </a:solidFill>
                 <a:latin typeface="Consolas"/>
               </a:rPr>
-            </a:br>
-            <a:br>
-              <a:rPr lang="en-IN" sz="2000" b="1" dirty="0">
-                <a:solidFill>
-                  <a:srgbClr val="7CDA6A"/>
-                </a:solidFill>
-                <a:latin typeface="Consolas"/>
-              </a:rPr>
-            </a:br>
-            <a:r>
-              <a:rPr sz="2000" b="1" dirty="0" err="1">
-                <a:solidFill>
-                  <a:srgbClr val="7CDA6A"/>
-                </a:solidFill>
-                <a:latin typeface="Consolas"/>
-              </a:rPr>
-              <a:t>sudo</a:t>
-            </a:r>
-            <a:r>
-              <a:rPr sz="2000" b="1" dirty="0">
-                <a:solidFill>
-                  <a:srgbClr val="7CDA6A"/>
-                </a:solidFill>
-                <a:latin typeface="Consolas"/>
-              </a:rPr>
-              <a:t> apt update</a:t>
+              <a:t>sudo apt update</a:t>
             </a:r>
           </a:p>
           <a:p>
             <a:pPr>
               <a:spcAft>
-                <a:spcPts val="1000"/>
+                <a:spcPts val="800"/>
               </a:spcAft>
             </a:pPr>
             <a:r>
-              <a:rPr sz="1800" b="1" dirty="0" err="1">
+              <a:rPr sz="1600" b="1">
                 <a:solidFill>
                   <a:srgbClr val="7CDA6A"/>
                 </a:solidFill>
                 <a:latin typeface="Consolas"/>
               </a:rPr>
-              <a:t>sudo</a:t>
-            </a:r>
-            <a:r>
-              <a:rPr sz="1800" b="1" dirty="0">
-                <a:solidFill>
-                  <a:srgbClr val="7CDA6A"/>
-                </a:solidFill>
-                <a:latin typeface="Consolas"/>
-              </a:rPr>
-              <a:t> apt install -y build-essential </a:t>
-            </a:r>
-            <a:r>
-              <a:rPr sz="1800" b="1" dirty="0" err="1">
-                <a:solidFill>
-                  <a:srgbClr val="7CDA6A"/>
-                </a:solidFill>
-                <a:latin typeface="Consolas"/>
-              </a:rPr>
-              <a:t>gcc-multilib</a:t>
-            </a:r>
-            <a:r>
-              <a:rPr sz="1800" b="1" dirty="0">
-                <a:solidFill>
-                  <a:srgbClr val="7CDA6A"/>
-                </a:solidFill>
-                <a:latin typeface="Consolas"/>
-              </a:rPr>
-              <a:t> </a:t>
-            </a:r>
-            <a:r>
-              <a:rPr sz="1800" b="1" dirty="0" err="1">
-                <a:solidFill>
-                  <a:srgbClr val="7CDA6A"/>
-                </a:solidFill>
-                <a:latin typeface="Consolas"/>
-              </a:rPr>
-              <a:t>gdb</a:t>
-            </a:r>
-            <a:r>
-              <a:rPr sz="1800" b="1" dirty="0">
-                <a:solidFill>
-                  <a:srgbClr val="7CDA6A"/>
-                </a:solidFill>
-                <a:latin typeface="Consolas"/>
-              </a:rPr>
-              <a:t> python3 </a:t>
-            </a:r>
-            <a:r>
-              <a:rPr sz="1800" b="1" dirty="0" err="1">
-                <a:solidFill>
-                  <a:srgbClr val="7CDA6A"/>
-                </a:solidFill>
-                <a:latin typeface="Consolas"/>
-              </a:rPr>
-              <a:t>hexedit</a:t>
-            </a:r>
-            <a:r>
-              <a:rPr sz="1800" b="1" dirty="0">
-                <a:solidFill>
-                  <a:srgbClr val="7CDA6A"/>
-                </a:solidFill>
-                <a:latin typeface="Consolas"/>
-              </a:rPr>
-              <a:t> bless</a:t>
+              <a:t>sudo apt install -y build-essential gcc-multilib gdb python3 hexedit bless</a:t>
             </a:r>
           </a:p>
           <a:p>
             <a:pPr>
               <a:spcAft>
-                <a:spcPts val="1000"/>
+                <a:spcPts val="800"/>
               </a:spcAft>
             </a:pPr>
             <a:r>
-              <a:rPr sz="2000" b="1" dirty="0">
+              <a:rPr sz="2000" b="1">
                 <a:solidFill>
                   <a:srgbClr val="7CDA6A"/>
                 </a:solidFill>
                 <a:latin typeface="Consolas"/>
               </a:rPr>
-              <a:t>bash -c "$(curl -</a:t>
-            </a:r>
-            <a:r>
-              <a:rPr sz="2000" b="1" dirty="0" err="1">
-                <a:solidFill>
-                  <a:srgbClr val="7CDA6A"/>
-                </a:solidFill>
-                <a:latin typeface="Consolas"/>
-              </a:rPr>
-              <a:t>fsSL</a:t>
-            </a:r>
-            <a:r>
-              <a:rPr sz="2000" b="1" dirty="0">
-                <a:solidFill>
-                  <a:srgbClr val="7CDA6A"/>
-                </a:solidFill>
-                <a:latin typeface="Consolas"/>
-              </a:rPr>
-              <a:t> https://gef.blah.cat/sh)"</a:t>
+              <a:t>sudo apt install openjdk-21-jdk -y</a:t>
             </a:r>
           </a:p>
           <a:p>
             <a:pPr>
               <a:spcAft>
-                <a:spcPts val="1000"/>
+                <a:spcPts val="800"/>
               </a:spcAft>
             </a:pPr>
-            <a:endParaRPr sz="2000" b="1" dirty="0">
-              <a:solidFill>
-                <a:srgbClr val="7CDA6A"/>
-              </a:solidFill>
-              <a:latin typeface="Consolas"/>
-            </a:endParaRPr>
+            <a:r>
+              <a:rPr sz="1800" b="1">
+                <a:solidFill>
+                  <a:srgbClr val="7CDA6A"/>
+                </a:solidFill>
+                <a:latin typeface="Consolas"/>
+              </a:rPr>
+              <a:t>bash -c "$(curl -fsSL https://gef.blah.cat/sh)"</a:t>
+            </a:r>
           </a:p>
           <a:p>
             <a:pPr>
               <a:spcAft>
-                <a:spcPts val="1000"/>
+                <a:spcPts val="800"/>
               </a:spcAft>
             </a:pPr>
             <a:r>
-              <a:rPr sz="1800" b="0" dirty="0">
+              <a:rPr sz="800" b="0">
                 <a:solidFill>
                   <a:srgbClr val="B0B0B0"/>
                 </a:solidFill>
                 <a:latin typeface="Calibri"/>
               </a:rPr>
-              <a:t>Then open a new terminal and run:   </a:t>
-            </a:r>
-            <a:r>
-              <a:rPr sz="1800" b="0" dirty="0" err="1">
-                <a:solidFill>
-                  <a:srgbClr val="B0B0B0"/>
-                </a:solidFill>
-                <a:latin typeface="Calibri"/>
-              </a:rPr>
-              <a:t>gdb</a:t>
-            </a:r>
-            <a:endParaRPr sz="1800" b="0" dirty="0">
-              <a:solidFill>
-                <a:srgbClr val="B0B0B0"/>
-              </a:solidFill>
-              <a:latin typeface="Calibri"/>
-            </a:endParaRPr>
+              <a:t/>
+            </a:r>
           </a:p>
           <a:p>
             <a:pPr>
               <a:spcAft>
-                <a:spcPts val="1000"/>
+                <a:spcPts val="800"/>
               </a:spcAft>
             </a:pPr>
             <a:r>
-              <a:rPr sz="1800" b="0" dirty="0">
+              <a:rPr sz="1600" b="0">
                 <a:solidFill>
                   <a:srgbClr val="B0B0B0"/>
                 </a:solidFill>
                 <a:latin typeface="Calibri"/>
               </a:rPr>
+              <a:t>openjdk-21-jdk  =  Java for Ghidra. Run that before ./ghidraRun.</a:t>
+            </a:r>
+          </a:p>
+          <a:p>
+            <a:pPr>
+              <a:spcAft>
+                <a:spcPts val="800"/>
+              </a:spcAft>
+            </a:pPr>
+            <a:r>
+              <a:rPr sz="1600" b="0">
+                <a:solidFill>
+                  <a:srgbClr val="B0B0B0"/>
+                </a:solidFill>
+                <a:latin typeface="Calibri"/>
+              </a:rPr>
+              <a:t>Then open a new terminal and run:   gdb</a:t>
+            </a:r>
+          </a:p>
+          <a:p>
+            <a:pPr>
+              <a:spcAft>
+                <a:spcPts val="800"/>
+              </a:spcAft>
+            </a:pPr>
+            <a:r>
+              <a:rPr sz="1600" b="0">
+                <a:solidFill>
+                  <a:srgbClr val="B0B0B0"/>
+                </a:solidFill>
+                <a:latin typeface="Calibri"/>
+              </a:rPr>
               <a:t>You should see a GEF banner. Same commands as vanilla GDB.</a:t>
             </a:r>
-            <a:br>
-              <a:rPr lang="en-IN">
-                <a:solidFill>
-                  <a:srgbClr val="B0B0B0"/>
-                </a:solidFill>
-              </a:rPr>
-            </a:br>
-            <a:br>
-              <a:rPr lang="en-IN">
-                <a:solidFill>
-                  <a:srgbClr val="B0B0B0"/>
-                </a:solidFill>
-              </a:rPr>
-            </a:br>
-            <a:r>
-              <a:rPr lang="en-IN">
-                <a:solidFill>
-                  <a:srgbClr val="B0B0B0"/>
-                </a:solidFill>
-              </a:rPr>
-              <a:t>Please go here : https://github.com/DERE-ad2001/reverse-engineering-101/tree/main</a:t>
-            </a:r>
-            <a:endParaRPr sz="1800" b="0" dirty="0">
-              <a:solidFill>
-                <a:srgbClr val="B0B0B0"/>
-              </a:solidFill>
-              <a:latin typeface="Calibri"/>
-            </a:endParaRPr>
           </a:p>
         </p:txBody>
       </p:sp>
@@ -3814,7 +3733,6 @@
           <a:lstStyle/>
           <a:p>
             <a:pPr algn="ctr"/>
-            <a:endParaRPr/>
           </a:p>
         </p:txBody>
       </p:sp>
@@ -9988,6 +9906,7 @@
           <a:lstStyle/>
           <a:p>
             <a:pPr algn="ctr"/>
+            <a:endParaRPr/>
           </a:p>
         </p:txBody>
       </p:sp>
@@ -10102,6 +10021,7 @@
           <a:lstStyle/>
           <a:p>
             <a:pPr algn="ctr"/>
+            <a:endParaRPr/>
           </a:p>
         </p:txBody>
       </p:sp>
@@ -10601,6 +10521,7 @@
           <a:lstStyle/>
           <a:p>
             <a:pPr algn="ctr"/>
+            <a:endParaRPr/>
           </a:p>
         </p:txBody>
       </p:sp>
@@ -10863,6 +10784,7 @@
           <a:lstStyle/>
           <a:p>
             <a:pPr algn="ctr"/>
+            <a:endParaRPr/>
           </a:p>
         </p:txBody>
       </p:sp>
@@ -11010,6 +10932,7 @@
           <a:lstStyle/>
           <a:p>
             <a:pPr algn="ctr"/>
+            <a:endParaRPr/>
           </a:p>
         </p:txBody>
       </p:sp>
@@ -11124,6 +11047,7 @@
           <a:lstStyle/>
           <a:p>
             <a:pPr algn="ctr"/>
+            <a:endParaRPr/>
           </a:p>
         </p:txBody>
       </p:sp>
@@ -11693,6 +11617,7 @@
           <a:lstStyle/>
           <a:p>
             <a:pPr algn="ctr"/>
+            <a:endParaRPr/>
           </a:p>
         </p:txBody>
       </p:sp>
@@ -11955,6 +11880,7 @@
           <a:lstStyle/>
           <a:p>
             <a:pPr algn="ctr"/>
+            <a:endParaRPr/>
           </a:p>
         </p:txBody>
       </p:sp>
@@ -12646,6 +12572,7 @@
           <a:lstStyle/>
           <a:p>
             <a:pPr algn="ctr"/>
+            <a:endParaRPr/>
           </a:p>
         </p:txBody>
       </p:sp>
@@ -12760,6 +12687,7 @@
           <a:lstStyle/>
           <a:p>
             <a:pPr algn="ctr"/>
+            <a:endParaRPr/>
           </a:p>
         </p:txBody>
       </p:sp>
@@ -13259,6 +13187,7 @@
           <a:lstStyle/>
           <a:p>
             <a:pPr algn="ctr"/>
+            <a:endParaRPr/>
           </a:p>
         </p:txBody>
       </p:sp>
@@ -13585,6 +13514,7 @@
           <a:lstStyle/>
           <a:p>
             <a:pPr algn="ctr"/>
+            <a:endParaRPr/>
           </a:p>
         </p:txBody>
       </p:sp>
@@ -13732,6 +13662,7 @@
           <a:lstStyle/>
           <a:p>
             <a:pPr algn="ctr"/>
+            <a:endParaRPr/>
           </a:p>
         </p:txBody>
       </p:sp>
@@ -13846,6 +13777,7 @@
           <a:lstStyle/>
           <a:p>
             <a:pPr algn="ctr"/>
+            <a:endParaRPr/>
           </a:p>
         </p:txBody>
       </p:sp>
@@ -14415,6 +14347,7 @@
           <a:lstStyle/>
           <a:p>
             <a:pPr algn="ctr"/>
+            <a:endParaRPr/>
           </a:p>
         </p:txBody>
       </p:sp>
@@ -14677,6 +14610,7 @@
           <a:lstStyle/>
           <a:p>
             <a:pPr algn="ctr"/>
+            <a:endParaRPr/>
           </a:p>
         </p:txBody>
       </p:sp>
@@ -14824,6 +14758,7 @@
           <a:lstStyle/>
           <a:p>
             <a:pPr algn="ctr"/>
+            <a:endParaRPr/>
           </a:p>
         </p:txBody>
       </p:sp>
@@ -14938,6 +14873,7 @@
           <a:lstStyle/>
           <a:p>
             <a:pPr algn="ctr"/>
+            <a:endParaRPr/>
           </a:p>
         </p:txBody>
       </p:sp>
@@ -15507,6 +15443,7 @@
           <a:lstStyle/>
           <a:p>
             <a:pPr algn="ctr"/>
+            <a:endParaRPr/>
           </a:p>
         </p:txBody>
       </p:sp>
@@ -15785,6 +15722,7 @@
           <a:lstStyle/>
           <a:p>
             <a:pPr algn="ctr"/>
+            <a:endParaRPr/>
           </a:p>
         </p:txBody>
       </p:sp>
@@ -15932,6 +15870,7 @@
           <a:lstStyle/>
           <a:p>
             <a:pPr algn="ctr"/>
+            <a:endParaRPr/>
           </a:p>
         </p:txBody>
       </p:sp>
@@ -16046,6 +15985,7 @@
           <a:lstStyle/>
           <a:p>
             <a:pPr algn="ctr"/>
+            <a:endParaRPr/>
           </a:p>
         </p:txBody>
       </p:sp>
@@ -16457,15 +16397,7 @@
           <a:lstStyle/>
           <a:p>
             <a:pPr algn="l"/>
-            <a:r>
-              <a:rPr sz="1600" b="1">
-                <a:solidFill>
-                  <a:srgbClr val="7CDA6A"/>
-                </a:solidFill>
-                <a:latin typeface="Consolas"/>
-              </a:rPr>
-              <a:t/>
-            </a:r>
+            <a:endParaRPr/>
           </a:p>
         </p:txBody>
       </p:sp>
@@ -16492,15 +16424,7 @@
           <a:lstStyle/>
           <a:p>
             <a:pPr algn="l"/>
-            <a:r>
-              <a:rPr sz="1500" b="0">
-                <a:solidFill>
-                  <a:srgbClr val="F2F2F2"/>
-                </a:solidFill>
-                <a:latin typeface="Consolas"/>
-              </a:rPr>
-              <a:t/>
-            </a:r>
+            <a:endParaRPr/>
           </a:p>
         </p:txBody>
       </p:sp>
@@ -16615,6 +16539,7 @@
           <a:lstStyle/>
           <a:p>
             <a:pPr algn="ctr"/>
+            <a:endParaRPr/>
           </a:p>
         </p:txBody>
       </p:sp>
@@ -16813,6 +16738,7 @@
           <a:lstStyle/>
           <a:p>
             <a:pPr algn="ctr"/>
+            <a:endParaRPr/>
           </a:p>
         </p:txBody>
       </p:sp>
@@ -17483,13 +17409,49 @@
           <a:p>
             <a:pPr algn="l"/>
             <a:r>
-              <a:rPr sz="1800" b="0">
+              <a:rPr sz="1800" b="0" dirty="0">
                 <a:solidFill>
                   <a:srgbClr val="F2F2F2"/>
                 </a:solidFill>
                 <a:latin typeface="Calibri"/>
               </a:rPr>
-              <a:t>Symbol Tree -&gt; Functions -&gt; main / add_one / is_ok.</a:t>
+              <a:t>Symbol Tree -&gt; Functions -&gt; main / </a:t>
+            </a:r>
+            <a:r>
+              <a:rPr sz="1800" b="0" dirty="0" err="1">
+                <a:solidFill>
+                  <a:srgbClr val="F2F2F2"/>
+                </a:solidFill>
+                <a:latin typeface="Calibri"/>
+              </a:rPr>
+              <a:t>add_one</a:t>
+            </a:r>
+            <a:r>
+              <a:rPr sz="1800" b="0" dirty="0">
+                <a:solidFill>
+                  <a:srgbClr val="F2F2F2"/>
+                </a:solidFill>
+                <a:latin typeface="Calibri"/>
+              </a:rPr>
+              <a:t> / </a:t>
+            </a:r>
+            <a:r>
+              <a:rPr sz="1800" b="0" dirty="0" err="1">
+                <a:solidFill>
+                  <a:srgbClr val="F2F2F2"/>
+                </a:solidFill>
+                <a:latin typeface="Calibri"/>
+              </a:rPr>
+              <a:t>is_ok</a:t>
+            </a:r>
+            <a:r>
+              <a:rPr sz="1800" b="0" dirty="0">
+                <a:solidFill>
+                  <a:srgbClr val="F2F2F2"/>
+                </a:solidFill>
+                <a:latin typeface="Calibri"/>
+              </a:rPr>
+              <a:t>.</a:t>
             </a:r>
           </a:p>
         </p:txBody>
@@ -18101,13 +18063,22 @@
           <a:p>
             <a:pPr algn="l"/>
             <a:r>
-              <a:rPr sz="2200" b="0">
+              <a:rPr sz="2200" b="0" dirty="0" err="1">
                 <a:solidFill>
                   <a:srgbClr val="F2F2F2"/>
                 </a:solidFill>
                 <a:latin typeface="Calibri"/>
               </a:rPr>
-              <a:t>gdb: break main, run, find the compare</a:t>
+              <a:t>gdb</a:t>
+            </a:r>
+            <a:r>
+              <a:rPr sz="2200" b="0" dirty="0">
+                <a:solidFill>
+                  <a:srgbClr val="F2F2F2"/>
+                </a:solidFill>
+                <a:latin typeface="Calibri"/>
+              </a:rPr>
+              <a:t>: break main, run, find the compare</a:t>
             </a:r>
           </a:p>
         </p:txBody>
@@ -18181,7 +18152,7 @@
           <a:p>
             <a:pPr algn="l"/>
             <a:r>
-              <a:rPr sz="2200" b="0">
+              <a:rPr sz="2200" b="0" dirty="0">
                 <a:solidFill>
                   <a:srgbClr val="F2F2F2"/>
                 </a:solidFill>
@@ -18976,135 +18947,54 @@
         </p:nvSpPr>
         <p:spPr>
           <a:xfrm>
-            <a:off x="640080" y="1920240"/>
-            <a:ext cx="10972800" cy="731520"/>
-          </a:xfrm>
-          <a:prstGeom prst="rect">
-            <a:avLst/>
-          </a:prstGeom>
-          <a:noFill/>
-        </p:spPr>
-        <p:txBody>
-          <a:bodyPr wrap="square">
-            <a:spAutoFit/>
-          </a:bodyPr>
-          <a:lstStyle/>
-          <a:p>
-            <a:pPr algn="l"/>
-            <a:r>
-              <a:rPr sz="3600" b="1">
+            <a:off x="788273" y="3094842"/>
+            <a:ext cx="10972800" cy="646331"/>
+          </a:xfrm>
+          <a:prstGeom prst="rect">
+            <a:avLst/>
+          </a:prstGeom>
+          <a:noFill/>
+        </p:spPr>
+        <p:txBody>
+          <a:bodyPr wrap="square">
+            <a:spAutoFit/>
+          </a:bodyPr>
+          <a:lstStyle/>
+          <a:p>
+            <a:pPr algn="l"/>
+            <a:r>
+              <a:rPr lang="en-IN" sz="3600" b="1" dirty="0">
                 <a:solidFill>
                   <a:srgbClr val="F2F2F2"/>
                 </a:solidFill>
                 <a:latin typeface="Calibri"/>
               </a:rPr>
-              <a:t>Done.</a:t>
-            </a:r>
-          </a:p>
-        </p:txBody>
-      </p:sp>
-      <p:sp>
-        <p:nvSpPr>
-          <p:cNvPr id="4" name="TextBox 3"/>
-          <p:cNvSpPr txBox="1"/>
-          <p:nvPr/>
-        </p:nvSpPr>
-        <p:spPr>
-          <a:xfrm>
-            <a:off x="640080" y="2834640"/>
-            <a:ext cx="10972800" cy="548640"/>
-          </a:xfrm>
-          <a:prstGeom prst="rect">
-            <a:avLst/>
-          </a:prstGeom>
-          <a:noFill/>
-        </p:spPr>
-        <p:txBody>
-          <a:bodyPr wrap="square">
-            <a:spAutoFit/>
-          </a:bodyPr>
-          <a:lstStyle/>
-          <a:p>
-            <a:pPr algn="l"/>
-            <a:r>
-              <a:rPr sz="2000" b="0">
-                <a:solidFill>
-                  <a:srgbClr val="B0B0B0"/>
-                </a:solidFill>
-                <a:latin typeface="Calibri"/>
-              </a:rPr>
-              <a:t>Rebuild the examples, step them again, then redo both crackmes without notes.</a:t>
-            </a:r>
-          </a:p>
-        </p:txBody>
-      </p:sp>
-      <p:sp>
-        <p:nvSpPr>
-          <p:cNvPr id="5" name="TextBox 4"/>
-          <p:cNvSpPr txBox="1"/>
-          <p:nvPr/>
-        </p:nvSpPr>
-        <p:spPr>
-          <a:xfrm>
-            <a:off x="640080" y="4023360"/>
-            <a:ext cx="10972800" cy="365760"/>
-          </a:xfrm>
-          <a:prstGeom prst="rect">
-            <a:avLst/>
-          </a:prstGeom>
-          <a:noFill/>
-        </p:spPr>
-        <p:txBody>
-          <a:bodyPr wrap="square">
-            <a:spAutoFit/>
-          </a:bodyPr>
-          <a:lstStyle/>
-          <a:p>
-            <a:pPr algn="l"/>
-            <a:r>
-              <a:rPr sz="2200" b="1">
+              <a:t>Any questions ? Or </a:t>
+            </a:r>
+            <a:r>
+              <a:rPr lang="en-IN" sz="3600" b="1" dirty="0" err="1">
                 <a:solidFill>
                   <a:srgbClr val="F2F2F2"/>
                 </a:solidFill>
                 <a:latin typeface="Calibri"/>
               </a:rPr>
-              <a:t>Ajin Deepak</a:t>
-            </a:r>
-          </a:p>
-        </p:txBody>
-      </p:sp>
-      <p:sp>
-        <p:nvSpPr>
-          <p:cNvPr id="6" name="TextBox 5"/>
-          <p:cNvSpPr txBox="1"/>
-          <p:nvPr/>
-        </p:nvSpPr>
-        <p:spPr>
-          <a:xfrm>
-            <a:off x="640080" y="4480560"/>
-            <a:ext cx="10972800" cy="365760"/>
-          </a:xfrm>
-          <a:prstGeom prst="rect">
-            <a:avLst/>
-          </a:prstGeom>
-          <a:noFill/>
-        </p:spPr>
-        <p:txBody>
-          <a:bodyPr wrap="square">
-            <a:spAutoFit/>
-          </a:bodyPr>
-          <a:lstStyle/>
-          <a:p>
-            <a:pPr algn="l"/>
-            <a:r>
-              <a:rPr sz="1800" b="0">
-                <a:solidFill>
-                  <a:srgbClr val="E8A23A"/>
-                </a:solidFill>
-                <a:latin typeface="Calibri"/>
-              </a:rPr>
-              <a:t>AntiBot Engineer  @  NielsenIQ</a:t>
-            </a:r>
+              <a:t>yall</a:t>
+            </a:r>
+            <a:r>
+              <a:rPr lang="en-IN" sz="3600" b="1" dirty="0">
+                <a:solidFill>
+                  <a:srgbClr val="F2F2F2"/>
+                </a:solidFill>
+                <a:latin typeface="Calibri"/>
+              </a:rPr>
+              <a:t> just wanted to get the hell out ?</a:t>
+            </a:r>
+            <a:endParaRPr sz="3600" b="1" dirty="0">
+              <a:solidFill>
+                <a:srgbClr val="F2F2F2"/>
+              </a:solidFill>
+              <a:latin typeface="Calibri"/>
+            </a:endParaRPr>
           </a:p>
         </p:txBody>
       </p:sp>

</xml_diff>

<commit_message>
Add x86 flags slide after Registers.
Co-authored-by: Cursor <cursoragent@cursor.com>
</commit_message>
<xml_diff>
--- a/Reverse Engineering 101.pptx
+++ b/Reverse Engineering 101.pptx
@@ -19,6 +19,7 @@
     <p:sldId id="267" r:id="rId13"/>
     <p:sldId id="268" r:id="rId14"/>
     <p:sldId id="269" r:id="rId15"/>
+    <p:sldId id="283" r:id="rId33"/>
     <p:sldId id="270" r:id="rId16"/>
     <p:sldId id="271" r:id="rId17"/>
     <p:sldId id="272" r:id="rId18"/>
@@ -33,7 +34,7 @@
     <p:sldId id="281" r:id="rId27"/>
     <p:sldId id="282" r:id="rId28"/>
   </p:sldIdLst>
-  <p:sldSz cx="12192000" cy="6858000"/>
+  <p:sldSz cx="12191695" cy="6858000"/>
   <p:notesSz cx="6858000" cy="9144000"/>
   <p:defaultTextStyle>
     <a:defPPr>
@@ -3801,7 +3802,7 @@
                 </a:solidFill>
                 <a:latin typeface="Calibri"/>
               </a:rPr>
-              <a:t>10 / 27</a:t>
+              <a:t>10 / 28</a:t>
             </a:r>
           </a:p>
         </p:txBody>
@@ -4331,7 +4332,7 @@
                 </a:solidFill>
                 <a:latin typeface="Calibri"/>
               </a:rPr>
-              <a:t>11 / 27</a:t>
+              <a:t>11 / 28</a:t>
             </a:r>
           </a:p>
         </p:txBody>
@@ -4940,7 +4941,7 @@
                 </a:solidFill>
                 <a:latin typeface="Calibri"/>
               </a:rPr>
-              <a:t>12 / 27</a:t>
+              <a:t>12 / 28</a:t>
             </a:r>
           </a:p>
         </p:txBody>
@@ -5581,7 +5582,7 @@
                 </a:solidFill>
                 <a:latin typeface="Calibri"/>
               </a:rPr>
-              <a:t>13 / 27</a:t>
+              <a:t>13 / 28</a:t>
             </a:r>
           </a:p>
         </p:txBody>
@@ -6393,7 +6394,7 @@
                 </a:solidFill>
                 <a:latin typeface="Calibri"/>
               </a:rPr>
-              <a:t>14 / 27</a:t>
+              <a:t>14 / 28</a:t>
             </a:r>
           </a:p>
         </p:txBody>
@@ -7151,7 +7152,7 @@
                 </a:solidFill>
                 <a:latin typeface="Calibri"/>
               </a:rPr>
-              <a:t>15 / 27</a:t>
+              <a:t>16 / 28</a:t>
             </a:r>
           </a:p>
         </p:txBody>
@@ -8909,7 +8910,7 @@
                 </a:solidFill>
                 <a:latin typeface="Calibri"/>
               </a:rPr>
-              <a:t>16 / 27</a:t>
+              <a:t>17 / 28</a:t>
             </a:r>
           </a:p>
         </p:txBody>
@@ -9827,7 +9828,7 @@
                 </a:solidFill>
                 <a:latin typeface="Calibri"/>
               </a:rPr>
-              <a:t>17 / 27</a:t>
+              <a:t>18 / 28</a:t>
             </a:r>
           </a:p>
         </p:txBody>
@@ -10853,7 +10854,7 @@
                 </a:solidFill>
                 <a:latin typeface="Calibri"/>
               </a:rPr>
-              <a:t>18 / 27</a:t>
+              <a:t>19 / 28</a:t>
             </a:r>
           </a:p>
         </p:txBody>
@@ -11949,7 +11950,7 @@
                 </a:solidFill>
                 <a:latin typeface="Calibri"/>
               </a:rPr>
-              <a:t>19 / 27</a:t>
+              <a:t>20 / 28</a:t>
             </a:r>
           </a:p>
         </p:txBody>
@@ -12493,7 +12494,7 @@
                 </a:solidFill>
                 <a:latin typeface="Calibri"/>
               </a:rPr>
-              <a:t>2 / 27</a:t>
+              <a:t>2 / 28</a:t>
             </a:r>
           </a:p>
         </p:txBody>
@@ -13583,7 +13584,7 @@
                 </a:solidFill>
                 <a:latin typeface="Calibri"/>
               </a:rPr>
-              <a:t>20 / 27</a:t>
+              <a:t>21 / 28</a:t>
             </a:r>
           </a:p>
         </p:txBody>
@@ -14679,7 +14680,7 @@
                 </a:solidFill>
                 <a:latin typeface="Calibri"/>
               </a:rPr>
-              <a:t>21 / 27</a:t>
+              <a:t>22 / 28</a:t>
             </a:r>
           </a:p>
         </p:txBody>
@@ -15791,7 +15792,7 @@
                 </a:solidFill>
                 <a:latin typeface="Calibri"/>
               </a:rPr>
-              <a:t>22 / 27</a:t>
+              <a:t>23 / 28</a:t>
             </a:r>
           </a:p>
         </p:txBody>
@@ -16807,7 +16808,7 @@
                 </a:solidFill>
                 <a:latin typeface="Calibri"/>
               </a:rPr>
-              <a:t>23 / 27</a:t>
+              <a:t>24 / 28</a:t>
             </a:r>
           </a:p>
         </p:txBody>
@@ -17681,7 +17682,7 @@
                 </a:solidFill>
                 <a:latin typeface="Calibri"/>
               </a:rPr>
-              <a:t>24 / 27</a:t>
+              <a:t>25 / 28</a:t>
             </a:r>
           </a:p>
         </p:txBody>
@@ -18273,7 +18274,7 @@
                 </a:solidFill>
                 <a:latin typeface="Calibri"/>
               </a:rPr>
-              <a:t>25 / 27</a:t>
+              <a:t>26 / 28</a:t>
             </a:r>
           </a:p>
         </p:txBody>
@@ -18856,7 +18857,7 @@
                 </a:solidFill>
                 <a:latin typeface="Calibri"/>
               </a:rPr>
-              <a:t>26 / 27</a:t>
+              <a:t>27 / 28</a:t>
             </a:r>
           </a:p>
         </p:txBody>
@@ -19006,6 +19007,891 @@
 </p:sld>
 </file>
 
+<file path=ppt/slides/slide28.xml><?xml version="1.0" encoding="utf-8"?>
+<p:sld xmlns:a="http://schemas.openxmlformats.org/drawingml/2006/main" xmlns:p="http://schemas.openxmlformats.org/presentationml/2006/main" xmlns:r="http://schemas.openxmlformats.org/officeDocument/2006/relationships">
+  <p:cSld>
+    <p:bg>
+      <p:bgPr>
+        <a:solidFill>
+          <a:srgbClr val="1A1A1A"/>
+        </a:solidFill>
+        <a:effectLst/>
+      </p:bgPr>
+    </p:bg>
+    <p:spTree>
+      <p:nvGrpSpPr>
+        <p:cNvPr id="1" name=""/>
+        <p:cNvGrpSpPr/>
+        <p:nvPr/>
+      </p:nvGrpSpPr>
+      <p:grpSpPr/>
+      <p:sp>
+        <p:nvSpPr>
+          <p:cNvPr id="2" name="Rectangle 1"/>
+          <p:cNvSpPr/>
+          <p:nvPr/>
+        </p:nvSpPr>
+        <p:spPr>
+          <a:xfrm>
+            <a:off x="0" y="0"/>
+            <a:ext cx="109728" cy="6858000"/>
+          </a:xfrm>
+          <a:prstGeom prst="rect">
+            <a:avLst/>
+          </a:prstGeom>
+          <a:solidFill>
+            <a:srgbClr val="E8A23A"/>
+          </a:solidFill>
+          <a:ln>
+            <a:noFill/>
+          </a:ln>
+          <a:effectLst/>
+        </p:spPr>
+        <p:style>
+          <a:lnRef idx="1">
+            <a:schemeClr val="accent1"/>
+          </a:lnRef>
+          <a:fillRef idx="3">
+            <a:schemeClr val="accent1"/>
+          </a:fillRef>
+          <a:effectRef idx="2">
+            <a:schemeClr val="accent1"/>
+          </a:effectRef>
+          <a:fontRef idx="minor">
+            <a:schemeClr val="lt1"/>
+          </a:fontRef>
+        </p:style>
+        <p:txBody>
+          <a:bodyPr rtlCol="0" anchor="ctr"/>
+          <a:lstStyle/>
+          <a:p>
+            <a:pPr algn="ctr"/>
+          </a:p>
+        </p:txBody>
+      </p:sp>
+      <p:sp>
+        <p:nvSpPr>
+          <p:cNvPr id="3" name="TextBox 2"/>
+          <p:cNvSpPr txBox="1"/>
+          <p:nvPr/>
+        </p:nvSpPr>
+        <p:spPr>
+          <a:xfrm>
+            <a:off x="411480" y="256032"/>
+            <a:ext cx="11338560" cy="502920"/>
+          </a:xfrm>
+          <a:prstGeom prst="rect">
+            <a:avLst/>
+          </a:prstGeom>
+          <a:noFill/>
+        </p:spPr>
+        <p:txBody>
+          <a:bodyPr wrap="square">
+            <a:spAutoFit/>
+          </a:bodyPr>
+          <a:lstStyle/>
+          <a:p>
+            <a:pPr algn="l"/>
+            <a:r>
+              <a:rPr sz="3200" b="1">
+                <a:solidFill>
+                  <a:srgbClr val="F2F2F2"/>
+                </a:solidFill>
+                <a:latin typeface="Calibri"/>
+              </a:rPr>
+              <a:t>Flags</a:t>
+            </a:r>
+          </a:p>
+        </p:txBody>
+      </p:sp>
+      <p:sp>
+        <p:nvSpPr>
+          <p:cNvPr id="4" name="TextBox 3"/>
+          <p:cNvSpPr txBox="1"/>
+          <p:nvPr/>
+        </p:nvSpPr>
+        <p:spPr>
+          <a:xfrm>
+            <a:off x="457200" y="868680"/>
+            <a:ext cx="11247120" cy="502920"/>
+          </a:xfrm>
+          <a:prstGeom prst="rect">
+            <a:avLst/>
+          </a:prstGeom>
+          <a:noFill/>
+        </p:spPr>
+        <p:txBody>
+          <a:bodyPr wrap="square">
+            <a:spAutoFit/>
+          </a:bodyPr>
+          <a:lstStyle/>
+          <a:p>
+            <a:pPr algn="l"/>
+            <a:r>
+              <a:rPr sz="1800" b="0">
+                <a:solidFill>
+                  <a:srgbClr val="B0B0B0"/>
+                </a:solidFill>
+                <a:latin typeface="Calibri"/>
+              </a:rPr>
+              <a:t>Bits in EFLAGS. Math and cmp write them. je / jne read them. Not a general-purpose register.</a:t>
+            </a:r>
+          </a:p>
+        </p:txBody>
+      </p:sp>
+      <p:sp>
+        <p:nvSpPr>
+          <p:cNvPr id="5" name="Rectangle 4"/>
+          <p:cNvSpPr/>
+          <p:nvPr/>
+        </p:nvSpPr>
+        <p:spPr>
+          <a:xfrm>
+            <a:off x="457200" y="1508760"/>
+            <a:ext cx="11247120" cy="868680"/>
+          </a:xfrm>
+          <a:prstGeom prst="rect">
+            <a:avLst/>
+          </a:prstGeom>
+          <a:solidFill>
+            <a:srgbClr val="242424"/>
+          </a:solidFill>
+          <a:ln>
+            <a:noFill/>
+          </a:ln>
+          <a:effectLst/>
+        </p:spPr>
+        <p:style>
+          <a:lnRef idx="1">
+            <a:schemeClr val="accent1"/>
+          </a:lnRef>
+          <a:fillRef idx="3">
+            <a:schemeClr val="accent1"/>
+          </a:fillRef>
+          <a:effectRef idx="2">
+            <a:schemeClr val="accent1"/>
+          </a:effectRef>
+          <a:fontRef idx="minor">
+            <a:schemeClr val="lt1"/>
+          </a:fontRef>
+        </p:style>
+        <p:txBody>
+          <a:bodyPr rtlCol="0" anchor="ctr"/>
+          <a:lstStyle/>
+          <a:p>
+            <a:pPr algn="ctr"/>
+          </a:p>
+        </p:txBody>
+      </p:sp>
+      <p:sp>
+        <p:nvSpPr>
+          <p:cNvPr id="6" name="TextBox 5"/>
+          <p:cNvSpPr txBox="1"/>
+          <p:nvPr/>
+        </p:nvSpPr>
+        <p:spPr>
+          <a:xfrm>
+            <a:off x="640080" y="1709928"/>
+            <a:ext cx="1005840" cy="457200"/>
+          </a:xfrm>
+          <a:prstGeom prst="rect">
+            <a:avLst/>
+          </a:prstGeom>
+          <a:noFill/>
+        </p:spPr>
+        <p:txBody>
+          <a:bodyPr wrap="square">
+            <a:spAutoFit/>
+          </a:bodyPr>
+          <a:lstStyle/>
+          <a:p>
+            <a:pPr algn="l"/>
+            <a:r>
+              <a:rPr sz="2200" b="1">
+                <a:solidFill>
+                  <a:srgbClr val="E8A23A"/>
+                </a:solidFill>
+                <a:latin typeface="Consolas"/>
+              </a:rPr>
+              <a:t>ZF</a:t>
+            </a:r>
+          </a:p>
+        </p:txBody>
+      </p:sp>
+      <p:sp>
+        <p:nvSpPr>
+          <p:cNvPr id="7" name="TextBox 6"/>
+          <p:cNvSpPr txBox="1"/>
+          <p:nvPr/>
+        </p:nvSpPr>
+        <p:spPr>
+          <a:xfrm>
+            <a:off x="1783080" y="1709928"/>
+            <a:ext cx="2286000" cy="457200"/>
+          </a:xfrm>
+          <a:prstGeom prst="rect">
+            <a:avLst/>
+          </a:prstGeom>
+          <a:noFill/>
+        </p:spPr>
+        <p:txBody>
+          <a:bodyPr wrap="square">
+            <a:spAutoFit/>
+          </a:bodyPr>
+          <a:lstStyle/>
+          <a:p>
+            <a:pPr algn="l"/>
+            <a:r>
+              <a:rPr sz="1800" b="1">
+                <a:solidFill>
+                  <a:srgbClr val="F2F2F2"/>
+                </a:solidFill>
+                <a:latin typeface="Calibri"/>
+              </a:rPr>
+              <a:t>zero flag</a:t>
+            </a:r>
+          </a:p>
+        </p:txBody>
+      </p:sp>
+      <p:sp>
+        <p:nvSpPr>
+          <p:cNvPr id="8" name="TextBox 7"/>
+          <p:cNvSpPr txBox="1"/>
+          <p:nvPr/>
+        </p:nvSpPr>
+        <p:spPr>
+          <a:xfrm>
+            <a:off x="4206240" y="1673351"/>
+            <a:ext cx="7223760" cy="548640"/>
+          </a:xfrm>
+          <a:prstGeom prst="rect">
+            <a:avLst/>
+          </a:prstGeom>
+          <a:noFill/>
+        </p:spPr>
+        <p:txBody>
+          <a:bodyPr wrap="square">
+            <a:spAutoFit/>
+          </a:bodyPr>
+          <a:lstStyle/>
+          <a:p>
+            <a:pPr algn="l"/>
+            <a:r>
+              <a:rPr sz="1600" b="0">
+                <a:solidFill>
+                  <a:srgbClr val="F2F2F2"/>
+                </a:solidFill>
+                <a:latin typeface="Calibri"/>
+              </a:rPr>
+              <a:t>Result was 0. xor eax, eax sets this. je / jz jump if ZF=1.</a:t>
+            </a:r>
+          </a:p>
+        </p:txBody>
+      </p:sp>
+      <p:sp>
+        <p:nvSpPr>
+          <p:cNvPr id="9" name="Rectangle 8"/>
+          <p:cNvSpPr/>
+          <p:nvPr/>
+        </p:nvSpPr>
+        <p:spPr>
+          <a:xfrm>
+            <a:off x="457200" y="2468880"/>
+            <a:ext cx="11247120" cy="868680"/>
+          </a:xfrm>
+          <a:prstGeom prst="rect">
+            <a:avLst/>
+          </a:prstGeom>
+          <a:solidFill>
+            <a:srgbClr val="242424"/>
+          </a:solidFill>
+          <a:ln>
+            <a:noFill/>
+          </a:ln>
+          <a:effectLst/>
+        </p:spPr>
+        <p:style>
+          <a:lnRef idx="1">
+            <a:schemeClr val="accent1"/>
+          </a:lnRef>
+          <a:fillRef idx="3">
+            <a:schemeClr val="accent1"/>
+          </a:fillRef>
+          <a:effectRef idx="2">
+            <a:schemeClr val="accent1"/>
+          </a:effectRef>
+          <a:fontRef idx="minor">
+            <a:schemeClr val="lt1"/>
+          </a:fontRef>
+        </p:style>
+        <p:txBody>
+          <a:bodyPr rtlCol="0" anchor="ctr"/>
+          <a:lstStyle/>
+          <a:p>
+            <a:pPr algn="ctr"/>
+          </a:p>
+        </p:txBody>
+      </p:sp>
+      <p:sp>
+        <p:nvSpPr>
+          <p:cNvPr id="10" name="TextBox 9"/>
+          <p:cNvSpPr txBox="1"/>
+          <p:nvPr/>
+        </p:nvSpPr>
+        <p:spPr>
+          <a:xfrm>
+            <a:off x="640080" y="2670048"/>
+            <a:ext cx="1005840" cy="457200"/>
+          </a:xfrm>
+          <a:prstGeom prst="rect">
+            <a:avLst/>
+          </a:prstGeom>
+          <a:noFill/>
+        </p:spPr>
+        <p:txBody>
+          <a:bodyPr wrap="square">
+            <a:spAutoFit/>
+          </a:bodyPr>
+          <a:lstStyle/>
+          <a:p>
+            <a:pPr algn="l"/>
+            <a:r>
+              <a:rPr sz="2200" b="1">
+                <a:solidFill>
+                  <a:srgbClr val="E8A23A"/>
+                </a:solidFill>
+                <a:latin typeface="Consolas"/>
+              </a:rPr>
+              <a:t>CF</a:t>
+            </a:r>
+          </a:p>
+        </p:txBody>
+      </p:sp>
+      <p:sp>
+        <p:nvSpPr>
+          <p:cNvPr id="11" name="TextBox 10"/>
+          <p:cNvSpPr txBox="1"/>
+          <p:nvPr/>
+        </p:nvSpPr>
+        <p:spPr>
+          <a:xfrm>
+            <a:off x="1783080" y="2670048"/>
+            <a:ext cx="2286000" cy="457200"/>
+          </a:xfrm>
+          <a:prstGeom prst="rect">
+            <a:avLst/>
+          </a:prstGeom>
+          <a:noFill/>
+        </p:spPr>
+        <p:txBody>
+          <a:bodyPr wrap="square">
+            <a:spAutoFit/>
+          </a:bodyPr>
+          <a:lstStyle/>
+          <a:p>
+            <a:pPr algn="l"/>
+            <a:r>
+              <a:rPr sz="1800" b="1">
+                <a:solidFill>
+                  <a:srgbClr val="F2F2F2"/>
+                </a:solidFill>
+                <a:latin typeface="Calibri"/>
+              </a:rPr>
+              <a:t>carry flag</a:t>
+            </a:r>
+          </a:p>
+        </p:txBody>
+      </p:sp>
+      <p:sp>
+        <p:nvSpPr>
+          <p:cNvPr id="12" name="TextBox 11"/>
+          <p:cNvSpPr txBox="1"/>
+          <p:nvPr/>
+        </p:nvSpPr>
+        <p:spPr>
+          <a:xfrm>
+            <a:off x="4206240" y="2633472"/>
+            <a:ext cx="7223760" cy="548640"/>
+          </a:xfrm>
+          <a:prstGeom prst="rect">
+            <a:avLst/>
+          </a:prstGeom>
+          <a:noFill/>
+        </p:spPr>
+        <p:txBody>
+          <a:bodyPr wrap="square">
+            <a:spAutoFit/>
+          </a:bodyPr>
+          <a:lstStyle/>
+          <a:p>
+            <a:pPr algn="l"/>
+            <a:r>
+              <a:rPr sz="1600" b="0">
+                <a:solidFill>
+                  <a:srgbClr val="F2F2F2"/>
+                </a:solidFill>
+                <a:latin typeface="Calibri"/>
+              </a:rPr>
+              <a:t>Unsigned carry / borrow from add / sub. inc / dec do not change CF.</a:t>
+            </a:r>
+          </a:p>
+        </p:txBody>
+      </p:sp>
+      <p:sp>
+        <p:nvSpPr>
+          <p:cNvPr id="13" name="Rectangle 12"/>
+          <p:cNvSpPr/>
+          <p:nvPr/>
+        </p:nvSpPr>
+        <p:spPr>
+          <a:xfrm>
+            <a:off x="457200" y="3429000"/>
+            <a:ext cx="11247120" cy="868680"/>
+          </a:xfrm>
+          <a:prstGeom prst="rect">
+            <a:avLst/>
+          </a:prstGeom>
+          <a:solidFill>
+            <a:srgbClr val="242424"/>
+          </a:solidFill>
+          <a:ln>
+            <a:noFill/>
+          </a:ln>
+          <a:effectLst/>
+        </p:spPr>
+        <p:style>
+          <a:lnRef idx="1">
+            <a:schemeClr val="accent1"/>
+          </a:lnRef>
+          <a:fillRef idx="3">
+            <a:schemeClr val="accent1"/>
+          </a:fillRef>
+          <a:effectRef idx="2">
+            <a:schemeClr val="accent1"/>
+          </a:effectRef>
+          <a:fontRef idx="minor">
+            <a:schemeClr val="lt1"/>
+          </a:fontRef>
+        </p:style>
+        <p:txBody>
+          <a:bodyPr rtlCol="0" anchor="ctr"/>
+          <a:lstStyle/>
+          <a:p>
+            <a:pPr algn="ctr"/>
+          </a:p>
+        </p:txBody>
+      </p:sp>
+      <p:sp>
+        <p:nvSpPr>
+          <p:cNvPr id="14" name="TextBox 13"/>
+          <p:cNvSpPr txBox="1"/>
+          <p:nvPr/>
+        </p:nvSpPr>
+        <p:spPr>
+          <a:xfrm>
+            <a:off x="640080" y="3630168"/>
+            <a:ext cx="1005840" cy="457200"/>
+          </a:xfrm>
+          <a:prstGeom prst="rect">
+            <a:avLst/>
+          </a:prstGeom>
+          <a:noFill/>
+        </p:spPr>
+        <p:txBody>
+          <a:bodyPr wrap="square">
+            <a:spAutoFit/>
+          </a:bodyPr>
+          <a:lstStyle/>
+          <a:p>
+            <a:pPr algn="l"/>
+            <a:r>
+              <a:rPr sz="2200" b="1">
+                <a:solidFill>
+                  <a:srgbClr val="E8A23A"/>
+                </a:solidFill>
+                <a:latin typeface="Consolas"/>
+              </a:rPr>
+              <a:t>SF</a:t>
+            </a:r>
+          </a:p>
+        </p:txBody>
+      </p:sp>
+      <p:sp>
+        <p:nvSpPr>
+          <p:cNvPr id="15" name="TextBox 14"/>
+          <p:cNvSpPr txBox="1"/>
+          <p:nvPr/>
+        </p:nvSpPr>
+        <p:spPr>
+          <a:xfrm>
+            <a:off x="1783080" y="3630168"/>
+            <a:ext cx="2286000" cy="457200"/>
+          </a:xfrm>
+          <a:prstGeom prst="rect">
+            <a:avLst/>
+          </a:prstGeom>
+          <a:noFill/>
+        </p:spPr>
+        <p:txBody>
+          <a:bodyPr wrap="square">
+            <a:spAutoFit/>
+          </a:bodyPr>
+          <a:lstStyle/>
+          <a:p>
+            <a:pPr algn="l"/>
+            <a:r>
+              <a:rPr sz="1800" b="1">
+                <a:solidFill>
+                  <a:srgbClr val="F2F2F2"/>
+                </a:solidFill>
+                <a:latin typeface="Calibri"/>
+              </a:rPr>
+              <a:t>sign flag</a:t>
+            </a:r>
+          </a:p>
+        </p:txBody>
+      </p:sp>
+      <p:sp>
+        <p:nvSpPr>
+          <p:cNvPr id="16" name="TextBox 15"/>
+          <p:cNvSpPr txBox="1"/>
+          <p:nvPr/>
+        </p:nvSpPr>
+        <p:spPr>
+          <a:xfrm>
+            <a:off x="4206240" y="3593592"/>
+            <a:ext cx="7223760" cy="548640"/>
+          </a:xfrm>
+          <a:prstGeom prst="rect">
+            <a:avLst/>
+          </a:prstGeom>
+          <a:noFill/>
+        </p:spPr>
+        <p:txBody>
+          <a:bodyPr wrap="square">
+            <a:spAutoFit/>
+          </a:bodyPr>
+          <a:lstStyle/>
+          <a:p>
+            <a:pPr algn="l"/>
+            <a:r>
+              <a:rPr sz="1600" b="0">
+                <a:solidFill>
+                  <a:srgbClr val="F2F2F2"/>
+                </a:solidFill>
+                <a:latin typeface="Calibri"/>
+              </a:rPr>
+              <a:t>Top bit of the result. 1 means negative if you treat it as signed.</a:t>
+            </a:r>
+          </a:p>
+        </p:txBody>
+      </p:sp>
+      <p:sp>
+        <p:nvSpPr>
+          <p:cNvPr id="17" name="Rectangle 16"/>
+          <p:cNvSpPr/>
+          <p:nvPr/>
+        </p:nvSpPr>
+        <p:spPr>
+          <a:xfrm>
+            <a:off x="457200" y="4389120"/>
+            <a:ext cx="11247120" cy="868680"/>
+          </a:xfrm>
+          <a:prstGeom prst="rect">
+            <a:avLst/>
+          </a:prstGeom>
+          <a:solidFill>
+            <a:srgbClr val="242424"/>
+          </a:solidFill>
+          <a:ln>
+            <a:noFill/>
+          </a:ln>
+          <a:effectLst/>
+        </p:spPr>
+        <p:style>
+          <a:lnRef idx="1">
+            <a:schemeClr val="accent1"/>
+          </a:lnRef>
+          <a:fillRef idx="3">
+            <a:schemeClr val="accent1"/>
+          </a:fillRef>
+          <a:effectRef idx="2">
+            <a:schemeClr val="accent1"/>
+          </a:effectRef>
+          <a:fontRef idx="minor">
+            <a:schemeClr val="lt1"/>
+          </a:fontRef>
+        </p:style>
+        <p:txBody>
+          <a:bodyPr rtlCol="0" anchor="ctr"/>
+          <a:lstStyle/>
+          <a:p>
+            <a:pPr algn="ctr"/>
+          </a:p>
+        </p:txBody>
+      </p:sp>
+      <p:sp>
+        <p:nvSpPr>
+          <p:cNvPr id="18" name="TextBox 17"/>
+          <p:cNvSpPr txBox="1"/>
+          <p:nvPr/>
+        </p:nvSpPr>
+        <p:spPr>
+          <a:xfrm>
+            <a:off x="640080" y="4590288"/>
+            <a:ext cx="1005840" cy="457200"/>
+          </a:xfrm>
+          <a:prstGeom prst="rect">
+            <a:avLst/>
+          </a:prstGeom>
+          <a:noFill/>
+        </p:spPr>
+        <p:txBody>
+          <a:bodyPr wrap="square">
+            <a:spAutoFit/>
+          </a:bodyPr>
+          <a:lstStyle/>
+          <a:p>
+            <a:pPr algn="l"/>
+            <a:r>
+              <a:rPr sz="2200" b="1">
+                <a:solidFill>
+                  <a:srgbClr val="E8A23A"/>
+                </a:solidFill>
+                <a:latin typeface="Consolas"/>
+              </a:rPr>
+              <a:t>OF</a:t>
+            </a:r>
+          </a:p>
+        </p:txBody>
+      </p:sp>
+      <p:sp>
+        <p:nvSpPr>
+          <p:cNvPr id="19" name="TextBox 18"/>
+          <p:cNvSpPr txBox="1"/>
+          <p:nvPr/>
+        </p:nvSpPr>
+        <p:spPr>
+          <a:xfrm>
+            <a:off x="1783080" y="4590288"/>
+            <a:ext cx="2286000" cy="457200"/>
+          </a:xfrm>
+          <a:prstGeom prst="rect">
+            <a:avLst/>
+          </a:prstGeom>
+          <a:noFill/>
+        </p:spPr>
+        <p:txBody>
+          <a:bodyPr wrap="square">
+            <a:spAutoFit/>
+          </a:bodyPr>
+          <a:lstStyle/>
+          <a:p>
+            <a:pPr algn="l"/>
+            <a:r>
+              <a:rPr sz="1800" b="1">
+                <a:solidFill>
+                  <a:srgbClr val="F2F2F2"/>
+                </a:solidFill>
+                <a:latin typeface="Calibri"/>
+              </a:rPr>
+              <a:t>overflow flag</a:t>
+            </a:r>
+          </a:p>
+        </p:txBody>
+      </p:sp>
+      <p:sp>
+        <p:nvSpPr>
+          <p:cNvPr id="20" name="TextBox 19"/>
+          <p:cNvSpPr txBox="1"/>
+          <p:nvPr/>
+        </p:nvSpPr>
+        <p:spPr>
+          <a:xfrm>
+            <a:off x="4206240" y="4553712"/>
+            <a:ext cx="7223760" cy="548640"/>
+          </a:xfrm>
+          <a:prstGeom prst="rect">
+            <a:avLst/>
+          </a:prstGeom>
+          <a:noFill/>
+        </p:spPr>
+        <p:txBody>
+          <a:bodyPr wrap="square">
+            <a:spAutoFit/>
+          </a:bodyPr>
+          <a:lstStyle/>
+          <a:p>
+            <a:pPr algn="l"/>
+            <a:r>
+              <a:rPr sz="1600" b="0">
+                <a:solidFill>
+                  <a:srgbClr val="F2F2F2"/>
+                </a:solidFill>
+                <a:latin typeface="Calibri"/>
+              </a:rPr>
+              <a:t>Signed overflow. The result does not fit in a signed value of that size.</a:t>
+            </a:r>
+          </a:p>
+        </p:txBody>
+      </p:sp>
+      <p:sp>
+        <p:nvSpPr>
+          <p:cNvPr id="21" name="TextBox 20"/>
+          <p:cNvSpPr txBox="1"/>
+          <p:nvPr/>
+        </p:nvSpPr>
+        <p:spPr>
+          <a:xfrm>
+            <a:off x="457200" y="5486400"/>
+            <a:ext cx="11247120" cy="777240"/>
+          </a:xfrm>
+          <a:prstGeom prst="rect">
+            <a:avLst/>
+          </a:prstGeom>
+          <a:noFill/>
+        </p:spPr>
+        <p:txBody>
+          <a:bodyPr wrap="square">
+            <a:spAutoFit/>
+          </a:bodyPr>
+          <a:lstStyle/>
+          <a:p>
+            <a:pPr algn="l"/>
+            <a:r>
+              <a:rPr sz="1600" b="0">
+                <a:solidFill>
+                  <a:srgbClr val="7CDA6A"/>
+                </a:solidFill>
+                <a:latin typeface="Consolas"/>
+              </a:rPr>
+              <a:t>gdb:  info registers eflags     print ($eflags &amp; 0x40)   non-zero means ZF is set</a:t>
+            </a:r>
+          </a:p>
+        </p:txBody>
+      </p:sp>
+      <p:sp>
+        <p:nvSpPr>
+          <p:cNvPr id="22" name="Rectangle 21"/>
+          <p:cNvSpPr/>
+          <p:nvPr/>
+        </p:nvSpPr>
+        <p:spPr>
+          <a:xfrm>
+            <a:off x="0" y="6601968"/>
+            <a:ext cx="12191695" cy="256032"/>
+          </a:xfrm>
+          <a:prstGeom prst="rect">
+            <a:avLst/>
+          </a:prstGeom>
+          <a:solidFill>
+            <a:srgbClr val="121212"/>
+          </a:solidFill>
+          <a:ln>
+            <a:noFill/>
+          </a:ln>
+          <a:effectLst/>
+        </p:spPr>
+        <p:style>
+          <a:lnRef idx="1">
+            <a:schemeClr val="accent1"/>
+          </a:lnRef>
+          <a:fillRef idx="3">
+            <a:schemeClr val="accent1"/>
+          </a:fillRef>
+          <a:effectRef idx="2">
+            <a:schemeClr val="accent1"/>
+          </a:effectRef>
+          <a:fontRef idx="minor">
+            <a:schemeClr val="lt1"/>
+          </a:fontRef>
+        </p:style>
+        <p:txBody>
+          <a:bodyPr rtlCol="0" anchor="ctr"/>
+          <a:lstStyle/>
+          <a:p>
+            <a:pPr algn="ctr"/>
+          </a:p>
+        </p:txBody>
+      </p:sp>
+      <p:sp>
+        <p:nvSpPr>
+          <p:cNvPr id="23" name="TextBox 22"/>
+          <p:cNvSpPr txBox="1"/>
+          <p:nvPr/>
+        </p:nvSpPr>
+        <p:spPr>
+          <a:xfrm>
+            <a:off x="365760" y="6601968"/>
+            <a:ext cx="7315200" cy="237744"/>
+          </a:xfrm>
+          <a:prstGeom prst="rect">
+            <a:avLst/>
+          </a:prstGeom>
+          <a:noFill/>
+        </p:spPr>
+        <p:txBody>
+          <a:bodyPr wrap="square">
+            <a:spAutoFit/>
+          </a:bodyPr>
+          <a:lstStyle/>
+          <a:p>
+            <a:pPr algn="l"/>
+            <a:r>
+              <a:rPr sz="1100" b="0">
+                <a:solidFill>
+                  <a:srgbClr val="B0B0B0"/>
+                </a:solidFill>
+                <a:latin typeface="Calibri"/>
+              </a:rPr>
+              <a:t>Reverse Engineering 101   |   Ajin Deepak</a:t>
+            </a:r>
+          </a:p>
+        </p:txBody>
+      </p:sp>
+      <p:sp>
+        <p:nvSpPr>
+          <p:cNvPr id="24" name="TextBox 23"/>
+          <p:cNvSpPr txBox="1"/>
+          <p:nvPr/>
+        </p:nvSpPr>
+        <p:spPr>
+          <a:xfrm>
+            <a:off x="9601200" y="6601968"/>
+            <a:ext cx="2194560" cy="237744"/>
+          </a:xfrm>
+          <a:prstGeom prst="rect">
+            <a:avLst/>
+          </a:prstGeom>
+          <a:noFill/>
+        </p:spPr>
+        <p:txBody>
+          <a:bodyPr wrap="square">
+            <a:spAutoFit/>
+          </a:bodyPr>
+          <a:lstStyle/>
+          <a:p>
+            <a:pPr algn="r"/>
+            <a:r>
+              <a:rPr sz="1100" b="0">
+                <a:solidFill>
+                  <a:srgbClr val="B0B0B0"/>
+                </a:solidFill>
+                <a:latin typeface="Calibri"/>
+              </a:rPr>
+              <a:t>15 / 28</a:t>
+            </a:r>
+          </a:p>
+        </p:txBody>
+      </p:sp>
+    </p:spTree>
+  </p:cSld>
+  <p:clrMapOvr>
+    <a:masterClrMapping/>
+  </p:clrMapOvr>
+</p:sld>
+</file>
+
 <file path=ppt/slides/slide3.xml><?xml version="1.0" encoding="utf-8"?>
 <p:sld xmlns:a="http://schemas.openxmlformats.org/drawingml/2006/main" xmlns:r="http://schemas.openxmlformats.org/officeDocument/2006/relationships" xmlns:p="http://schemas.openxmlformats.org/presentationml/2006/main">
   <p:cSld>
@@ -19429,7 +20315,7 @@
                 </a:solidFill>
                 <a:latin typeface="Calibri"/>
               </a:rPr>
-              <a:t>3 / 27</a:t>
+              <a:t>3 / 28</a:t>
             </a:r>
           </a:p>
         </p:txBody>
@@ -19859,7 +20745,7 @@
                 </a:solidFill>
                 <a:latin typeface="Calibri"/>
               </a:rPr>
-              <a:t>4 / 27</a:t>
+              <a:t>4 / 28</a:t>
             </a:r>
           </a:p>
         </p:txBody>
@@ -20549,7 +21435,7 @@
                 </a:solidFill>
                 <a:latin typeface="Calibri"/>
               </a:rPr>
-              <a:t>5 / 27</a:t>
+              <a:t>5 / 28</a:t>
             </a:r>
           </a:p>
         </p:txBody>
@@ -21268,7 +22154,7 @@
                 </a:solidFill>
                 <a:latin typeface="Calibri"/>
               </a:rPr>
-              <a:t>6 / 27</a:t>
+              <a:t>6 / 28</a:t>
             </a:r>
           </a:p>
         </p:txBody>
@@ -22131,7 +23017,7 @@
                 </a:solidFill>
                 <a:latin typeface="Calibri"/>
               </a:rPr>
-              <a:t>7 / 27</a:t>
+              <a:t>7 / 28</a:t>
             </a:r>
           </a:p>
         </p:txBody>
@@ -23011,7 +23897,7 @@
                 </a:solidFill>
                 <a:latin typeface="Calibri"/>
               </a:rPr>
-              <a:t>8 / 27</a:t>
+              <a:t>8 / 28</a:t>
             </a:r>
           </a:p>
         </p:txBody>
@@ -24044,7 +24930,7 @@
                 </a:solidFill>
                 <a:latin typeface="Calibri"/>
               </a:rPr>
-              <a:t>9 / 27</a:t>
+              <a:t>9 / 28</a:t>
             </a:r>
           </a:p>
         </p:txBody>

</xml_diff>